<commit_message>
docs: presentation de soutenance en registre factuel
Reecrit le support de soutenance et le script parle sans metaphores :
les composants sont nommes par leur nom reel (load balancer, bastion,
serveurs EC2, base RDS MySQL, disque partage EFS) avec les ports
correspondants, et les phrases sont courtes et directes.

- 12 diapositives : besoin, architecture, choix techniques, Terraform,
  Ansible, montee en charge, pannes, problemes rencontres, limites,
  demonstration, bilan
- script parle : ordre de passage pour trois personnes, minutage,
  quatre etapes de demo, sept reponses preparees aux questions
- generateur pptxgenjs conserve a cote du .pptx pour pouvoir regenerer

Co-Authored-By: Claude Opus 5 <noreply@anthropic.com>
Claude-Session: https://claude.ai/code/session_018ABZHHV3NVYucierxWNFBR
</commit_message>
<xml_diff>
--- a/docs/soutenance-5hash.pptx
+++ b/docs/soutenance-5hash.pptx
@@ -513,9 +513,9 @@
           <a:p>
             <a:r>
               <a:rPr lang="en-US" dirty="0"/>
-              <a:t>Bonjour à tous. On est l'agence 5HASH, et Taylor Shift nous a confié sa boutique de billets.
-Le site, il existe déjà : c'est PrestaShop. Nous, on ne touche pas au site. Notre travail, c'est de lui construire une maison — et surtout une maison qui tient debout le jour où des milliers de fans se connectent en même temps.
-Tout est écrit en code : Terraform pour construire, Ansible pour installer. Et ce n'est pas une maquette : ça tourne en ce moment sur un vrai compte AWS. On vous le montrera à la fin.</a:t>
+              <a:t>Bonjour. Nous sommes l'agence 5HASH. Taylor Shift nous a confié l'infrastructure de sa boutique de billets.
+L'application existe déjà : c'est PrestaShop, l'image publiée sur Docker Hub. Nous ne touchons pas au code du site. Notre travail, c'est de l'héberger, de le configurer, et de faire en sorte qu'il tienne le jour de l'ouverture des ventes.
+Nous avons utilisé deux outils : Terraform pour créer l'infrastructure, Ansible pour configurer les serveurs. Tout est déployé sur un compte AWS réel, en région Paris. Nous ferons une démonstration à la fin.</a:t>
             </a:r>
             <a:endParaRPr lang="en-US" dirty="0"/>
           </a:p>
@@ -603,11 +603,11 @@
           <a:p>
             <a:r>
               <a:rPr lang="en-US" dirty="0"/>
-              <a:t>Une infrastructure dont on ne connaît pas les limites, c'est une infrastructure qu'on n'a pas comprise. Voilà les nôtres, en toute transparence.
-La première, la plus importante : ajouter des serveurs, ça demande quelqu'un. Ce n'est pas automatique. Un pic soudain, il faut un opérateur et deux commandes — trois minutes. Pour l'automatiser vraiment, il faudrait préparer à l'avance une image toute faite du serveur, avec tout déjà installé. Et bonne nouvelle : notre installation est déjà écrite pour ça, c'est une évolution, pas une réécriture.
-La deuxième : on a mis tout le site sur le disque partagé. C'est ce qui rend les serveurs interchangeables, mais un disque réseau est plus lent qu'un disque local. Au-delà de quelques milliers de visiteurs par minute, il faudrait mettre le site dans l'image et ne garder que les photos sur le disque partagé.
-La troisième : une seule base pour écrire. On peut ajouter des copies pour la lecture, mais une billetterie, ça écrit surtout.
-Et la quatrième : une seule région. Si toute la région Paris tombe, on tombe. Doubler ailleurs coûterait plus cher que la panne qu'on évite. C'est assumé.</a:t>
+              <a:t>Voici les limites de notre solution.
+Première limite, la principale : la montée en charge n'est pas automatique. Elle demande un opérateur et deux commandes, environ trois minutes. Pour l'automatiser, il faudrait construire à l'avance une image serveur préconfigurée, avec Packer, puis utiliser un groupe d'autoscaling derrière le même load balancer. Notre rôle Ansible et notre page de santé sont déjà compatibles avec cette évolution.
+Deuxième limite : le site entier est sur le disque partagé. Cela rend les serveurs interchangeables, mais un disque réseau est plus lent qu'un disque local pour lire des fichiers PHP. Au-delà de quelques milliers de requêtes par minute, il faudrait mettre le code dans l'image Docker et ne partager que les images produits.
+Troisième limite : une seule base en écriture. On peut répartir les lectures sur des réplicas, pas les écritures. Une billetterie écrit beaucoup, donc la taille de l'instance principale est notre plafond.
+Quatrième limite : une seule région. Une panne régionale interrompt le service. À cette échelle, le multi-région coûterait plus cher que la panne qu'il évite. C'est un choix, pas un oubli.</a:t>
             </a:r>
             <a:endParaRPr lang="en-US" dirty="0"/>
           </a:p>
@@ -695,11 +695,11 @@
           <a:p>
             <a:r>
               <a:rPr lang="en-US" dirty="0"/>
-              <a:t>Voilà tout ce qu'il y a à taper. Six commandes.
-La première, on ne la lance qu'une fois par compte : elle prépare l'endroit où Terraform range sa description de l'infrastructure.
-Ensuite Terraform construit. Une douzaine de minutes, et c'est la base de données qui prend tout le temps.
-Puis Ansible installe. Regardez bien la commande du milieu : c'est celle qui affiche la liste des serveurs. Aucune adresse n'y est écrite, elle est lue chez Terraform.
-On va vous montrer quatre choses : la boutique et son administration ; l'installation relancée qui ne change rien ; un serveur ajouté qui entre tout seul en service ; et enfin on en coupe un, en direct, pour vous montrer que la boutique tient.</a:t>
+              <a:t>Voici l'ensemble des commandes nécessaires.
+La première ne se lance qu'une fois par compte AWS : elle crée le bucket S3 qui stocke l'état Terraform.
+Ensuite, Terraform : init puis apply. L'opération prend une douzaine de minutes, dont la majorité pour la création de la base de données.
+Puis Ansible : on installe les dépendances depuis Galaxy, on vérifie l'inventaire, et on lance le playbook. La commande du milieu affiche la liste des serveurs : aucune adresse n'y est écrite, elle vient de l'état Terraform.
+Nous allons vous montrer quatre choses : la boutique et son back-office, le playbook relancé qui n'affiche aucune modification, l'ajout d'un serveur, et enfin l'arrêt d'un serveur pour montrer que le site continue de répondre.</a:t>
             </a:r>
             <a:endParaRPr lang="en-US" dirty="0"/>
           </a:p>
@@ -787,14 +787,14 @@
           <a:p>
             <a:r>
               <a:rPr lang="en-US" dirty="0"/>
-              <a:t>Pour conclure. La boutique est en ligne sur un vrai compte AWS. Elle est documentée : le README explique comment l'installer, la faire grandir, la dépanner et la supprimer. Et on sait la refaire : on l'a détruite et redéployée pour en être sûrs.
-Merci de votre attention, on est prêts pour vos questions.
-[Réponses courtes à avoir en tête :
-— Pourquoi pas d'ajout automatique de serveurs ? Parce qu'on installe les serveurs avec Ansible après leur création. Pour automatiser, il faudrait une image toute prête. On a préféré livrer quelque chose qui marche et dont on connaît la limite.
-— Pourquoi EFS et pas S3 ? Parce que PrestaShop écrit sur un disque, tout simplement. S3 demanderait un module en plus.
-— Où est le mot de passe de la base ? Nulle part chez nous. AWS le garde, et chaque serveur va le chercher avec sa propre autorisation.
-— Combien ça coûte ? Deux à trois dollars par jour pour l'environnement de test.
-— Comment vous changez de version de PrestaShop ? Une ligne dans un fichier Ansible, on relance, et on prend une sauvegarde de la base avant.]</a:t>
+              <a:t>Pour conclure. La boutique est déployée sur un compte AWS réel. Elle est documentée : le README explique comment la déployer, l'exploiter, la mettre à l'échelle, la dépanner et la supprimer. Et elle est reproductible : nous l'avons détruite et redéployée pour le vérifier.
+Merci de votre attention, nous répondons à vos questions.
+[Réponses préparées :
+— Pourquoi pas d'autoscaling ? Parce que nos serveurs sont configurés par Ansible après leur création. Un groupe d'autoscaling lancerait des machines non configurées. Il faudrait d'abord construire une image préconfigurée avec Packer.
+— Pourquoi EFS et pas S3 ? Parce que PrestaShop écrit sur un système de fichiers. Utiliser S3 demanderait un module PrestaShop supplémentaire.
+— Où est le mot de passe de la base ? Dans AWS Secrets Manager. Terraform le génère, chaque serveur le lit avec son rôle IAM. Il n'est ni dans le dépôt, ni dans l'inventaire Ansible.
+— Combien ça coûte ? Environ deux à trois dollars par jour pour l'environnement dev. Les postes principaux sont la passerelle NAT et le load balancer.
+— Comment changer de version de PrestaShop ? C'est une variable dans les group_vars Ansible. On modifie le tag de l'image et on relance le playbook, après une sauvegarde de la base.]</a:t>
             </a:r>
             <a:endParaRPr lang="en-US" dirty="0"/>
           </a:p>
@@ -882,11 +882,11 @@
           <a:p>
             <a:r>
               <a:rPr lang="en-US" dirty="0"/>
-              <a:t>Avant de choisir la moindre technologie, on s'est posé trois questions toutes bêtes.
-Un : comment un client arrive jusqu'à la boutique ? Autrement dit, par où ça rentre, et qu'est-ce qu'on laisse ouvert.
-Deux : et si dix fois plus de monde arrive d'un coup ? Parce qu'une ouverture de billetterie, ce n'est pas un trafic régulier. C'est un mur.
-Trois : et si une machine tombe ? Parce qu'une machine finit toujours par tomber.
-Tout ce qu'on va vous montrer répond à l'une de ces trois questions.</a:t>
+              <a:t>Avant de choisir les technologies, nous avons posé trois questions.
+Première question : par où passent les requêtes ? C'est la question du réseau et de la sécurité. Notre réponse : un seul point d'entrée public, et tout le reste dans des réseaux privés.
+Deuxième question : comment absorber un pic de trafic ? Une ouverture de billetterie, c'est un pic, pas une charge régulière. Notre réponse : les serveurs ne stockent aucune donnée, donc on peut en ajouter à la demande.
+Troisième question : que se passe-t-il en cas de panne ? Notre réponse : le load balancer retire automatiquement le serveur en panne, et les autres continuent.
+Chaque choix que nous présentons ensuite répond à l'une de ces trois questions.</a:t>
             </a:r>
             <a:endParaRPr lang="en-US" dirty="0"/>
           </a:p>
@@ -974,12 +974,11 @@
           <a:p>
             <a:r>
               <a:rPr lang="en-US" dirty="0"/>
-              <a:t>Pour expliquer l'architecture, on va prendre l'image d'une salle de concert. Ça se lit de haut en bas, comme le trajet d'un client.
-En haut, côté rue, il y a UNE seule porte : le répartiteur. C'est l'hôte d'accueil. Il envoie chaque visiteur vers une caisse libre, et il vérifie toutes les quinze secondes que chaque caisse va bien. Si une caisse ne répond plus, il arrête d'y envoyer du monde.
-À côté, l'entrée de service. Elle, elle est réservée à l'équipe : c'est par là qu'on passe pour installer et dépanner. Elle est ouverte à une seule adresse, la nôtre. Aucun client ne passe par là.
-Au milieu, les caisses : ce sont les serveurs qui font tourner la boutique. Elles sont toutes identiques. Et surtout, elles ne sont pas joignables depuis Internet — on ne peut y arriver qu'en passant par la porte d'accueil.
-En bas, les réserves. Le coffre, c'est la base de données : les billets, les paniers, les commandes. Le vestiaire, c'est un disque partagé : les images du site, le thème, et les paniers en cours.
-Et voilà le point important : les caisses ne gardent rien. Tout est dans le coffre et dans le vestiaire. C'est exactement ce qui va nous permettre d'en ajouter ou d'en perdre sans que personne ne s'en aperçoive.</a:t>
+              <a:t>Voici l'architecture. Elle se lit de haut en bas, dans le sens d'une requête.
+Premier niveau, le réseau public. Il contient deux choses. Le load balancer, qui est le seul point d'entrée des clients : il répartit les requêtes entre les serveurs et vérifie leur état toutes les quinze secondes. Et le bastion, qui sert uniquement à notre accès SSH : il est ouvert à une seule adresse IP, la nôtre. Aucun client ne passe par le bastion.
+Deuxième niveau, le réseau privé applicatif. Il contient les serveurs EC2, avec le conteneur PrestaShop. Ils sont identiques entre eux, répartis sur les deux zones de disponibilité, et ils n'ont aucune adresse IP publique : on ne peut les joindre qu'à travers le load balancer.
+Troisième niveau, le réseau privé des données. La base MySQL d'un côté, le disque partagé de l'autre. Ce niveau n'a aucune route vers Internet.
+Le point à retenir : les serveurs ne stockent aucune donnée. Le catalogue et les commandes sont dans la base, les images et les sessions sur le disque partagé. C'est ce qui permet d'ajouter ou de perdre un serveur sans conséquence.</a:t>
             </a:r>
             <a:endParaRPr lang="en-US" dirty="0"/>
           </a:p>
@@ -1067,11 +1066,13 @@
           <a:p>
             <a:r>
               <a:rPr lang="en-US" dirty="0"/>
-              <a:t>Le sujet nous laissait libres : ce qui tourne sur nos serveurs, et ce qu'on confie à AWS. Voilà comment on a tranché.
-La boutique tourne dans un conteneur Docker, sur un serveur EC2. C'est ce que demande le sujet, et ça nous arrange : changer de version de PrestaShop, c'est une seule ligne à modifier.
-La base de données, par contre, on ne veut pas la gérer. AWS s'occupe des sauvegardes, des mises à jour, et garde une machine de secours prête à prendre le relais. Franchement, personne n'a envie de découvrir un problème de base de données le soir de l'ouverture des ventes.
-Pour les fichiers, il nous fallait un disque que plusieurs serveurs voient en même temps. Un disque classique ne se partage pas. EFS, si.
-Et les mots de passe : celui de la base n'est écrit nulle part dans notre code. Terraform le génère, le dépose dans le coffre d'AWS, et chaque serveur va le chercher tout seul avec sa propre autorisation. Dans le dépôt, il n'y a que le mot de passe de l'administration du site, et il est chiffré.</a:t>
+              <a:t>Le sujet nous laissait libres de choisir ce qui tourne sur EC2 et ce qu'on confie à un service managé. Voici nos choix.
+L'application tourne dans un conteneur Docker sur une instance EC2. C'est ce que demande le sujet. Le conteneur donne un environnement identique partout, et changer de version de PrestaShop revient à modifier une ligne.
+La base de données est managée, c'est RDS. AWS gère les sauvegardes automatiques, les mises à jour de sécurité, et le basculement vers une instance de secours. Nous n'avons pas voulu réécrire ça nous-mêmes.
+Pour les fichiers, il fallait un stockage que plusieurs serveurs lisent et écrivent en même temps. Un disque EBS ne se partage pas entre instances, EFS si.
+Pour le point d'entrée, le load balancer surveille les serveurs et répartit les requêtes entre les deux zones.
+Pour les secrets, le mot de passe de la base est généré par Terraform et déposé dans Secrets Manager. Il n'est pas dans le dépôt. Chaque serveur va le chercher avec son propre rôle IAM. Seuls les identifiants du back-office sont dans le dépôt, et ils sont chiffrés avec Ansible Vault.
+Enfin, les serveurs n'ont pas d'adresse publique. L'accès administration passe par un bastion, ouvert à notre seule adresse IP.</a:t>
             </a:r>
             <a:endParaRPr lang="en-US" dirty="0"/>
           </a:p>
@@ -1159,11 +1160,11 @@
           <a:p>
             <a:r>
               <a:rPr lang="en-US" dirty="0"/>
-              <a:t>Terraform, c'est l'outil qui construit. On lui décrit ce qu'on veut, il se débrouille pour le créer.
-On a découpé en six briques, une par couche : le réseau, les droits, le disque, la base, les serveurs, et l'entrée. Chaque brique se relit toute seule, et si on veut en changer une, on ne casse pas les autres.
-Le truc dont on est contents : les trois environnements. Test, pré-production, production. C'est exactement le même code. On change un mot, et on passe d'un serveur à trois serveurs répartis sur trois zones, avec une base qui a une machine de secours et deux semaines de sauvegardes.
-La description de l'infrastructure est stockée sur AWS, pas sur nos ordinateurs, et elle est verrouillée : à trois, on ne peut pas se marcher dessus.
-Et rien n'est écrit en dur. Terraform va même chercher notre adresse IP du moment, et c'est la seule qui aura le droit de se connecter aux serveurs.</a:t>
+              <a:t>Terraform crée l'infrastructure. On décrit les ressources voulues, Terraform les crée et retient ce qu'il a créé.
+Nous avons découpé le code en six modules, un par couche : le réseau, les groupes de sécurité, le stockage, la base, les instances et le load balancer. Chaque module a ses variables documentées et ses sorties. On peut en relire un sans lire les autres.
+Pour les environnements, nous avons dev, staging et prod. C'est le même code. Une table de variables définit les tailles : en dev, un serveur et une base simple ; en prod, trois serveurs sur trois zones, une base avec instance de secours, et quatorze jours de sauvegardes. On change une variable, pas le code.
+L'état Terraform, c'est-à-dire la liste de ce qui a été créé, est stocké dans un bucket S3 versionné et chiffré, avec un verrou. C'est nécessaire à trois : sans ça, deux personnes peuvent modifier l'infrastructure en même temps.
+Enfin, trois valeurs sont lues automatiquement à l'exécution : l'identifiant de l'image Ubuntu, la liste des zones disponibles, et notre adresse IP publique. Cette dernière sert à autoriser l'accès SSH au bastion.</a:t>
             </a:r>
             <a:endParaRPr lang="en-US" dirty="0"/>
           </a:p>
@@ -1251,11 +1252,12 @@
           <a:p>
             <a:r>
               <a:rPr lang="en-US" dirty="0"/>
-              <a:t>Ansible, c'est l'outil qui installe. Une fois que Terraform a construit les machines, Ansible les configure.
-Le problème classique, c'est de faire le lien entre les deux : Terraform crée un serveur, et il faut donner son adresse à Ansible. Beaucoup de gens recopient à la main. Nous, non.
-Terraform écrit la liste des serveurs dans sa propre description, et Ansible va la lire directement chez lui. Résultat : il n'y a pas une seule adresse IP écrite à la main dans tout le projet. On crée un serveur avec Terraform, il apparaît tout seul dans la liste d'Ansible.
-On a écrit trois rôles réutilisables. Le serveur d'entrée et les caisses partagent le même rôle de base, juste avec des réglages différents. Et pour Docker, on a pris un rôle public, installé depuis Ansible Galaxy, plutôt que de le réécrire.
-Et le point le plus important, celui du barème : on peut relancer l'installation autant de fois qu'on veut. La deuxième fois, Ansible affiche « changed égale zéro ». Il ne touche à rien, parce que tout est déjà comme demandé. Ce n'est pas de la chance : on a conçu l'installation pour ça.</a:t>
+              <a:t>Ansible configure les serveurs créés par Terraform : il installe Docker, monte le disque partagé, récupère le mot de passe de la base et démarre le conteneur PrestaShop.
+Le point d'intégration entre les deux outils est ici. Terraform connaît les adresses des serveurs. Plutôt que de les recopier dans un fichier d'inventaire, Terraform les déclare dans son état, et Ansible les lit depuis cet état avec un plugin d'inventaire dynamique.
+Conséquence : il n'y a aucune adresse IP écrite à la main dans le projet. Quand on ajoute un serveur avec Terraform, il apparaît automatiquement dans l'inventaire Ansible.
+Nous avons écrit trois rôles réutilisables : common, efs et prestashop. Le bastion et les serveurs applicatifs utilisent le même rôle common, avec des variables différentes. Pour Docker, nous avons utilisé un rôle existant d'Ansible Galaxy plutôt que de le réécrire.
+Les identifiants du back-office sont chiffrés avec Ansible Vault. Le mot de passe de la base n'est pas dans le dépôt du tout.
+Enfin, le playbook est idempotent : il décrit l'état voulu, pas une suite d'étapes. À la deuxième exécution, il affiche changed égale zéro : il ne modifie rien, parce que tout est déjà en place.</a:t>
             </a:r>
             <a:endParaRPr lang="en-US" dirty="0"/>
           </a:p>
@@ -1343,10 +1345,10 @@
           <a:p>
             <a:r>
               <a:rPr lang="en-US" dirty="0"/>
-              <a:t>On arrive à la question qui compte vraiment : le jour où les billets partent en vente.
-Nos serveurs ne gardent rien. Une commande va dans la base, une image sur le disque partagé, un panier aussi. Résultat : ajouter de la capacité, c'est littéralement changer un chiffre.
-Deux commandes. La première crée les serveurs et les répartit sur les zones. La deuxième les installe — et seulement eux, parce qu'Ansible ne touche pas à ceux qui travaillent déjà. Trois minutes, sans couper la boutique.
-Et on ne décide pas au hasard. AWS surveille trois choses pour nous et nous envoie un mail : si le site devient lent, si un serveur ne répond plus, ou si la boutique renvoie des erreurs. C'est ça qui nous dit quand ajouter des machines.</a:t>
+              <a:t>Voici comment nous répondons à un pic de trafic.
+Les serveurs ne stockent aucune donnée : les commandes sont dans la base, les images et les sessions sur le disque partagé. Ajouter de la capacité revient donc à modifier une variable.
+Deux commandes. La première, Terraform, crée les serveurs, les répartit sur les zones et les enregistre auprès du load balancer. La deuxième, Ansible, les configure. Comme le playbook est idempotent, il ne touche pas aux serveurs déjà en service. L'opération prend environ trois minutes, sans interruption.
+Pour savoir quand le faire, trois alarmes CloudWatch sont créées avec le load balancer. La première surveille le temps de réponse : au-delà de deux secondes en moyenne sur trois minutes, les serveurs saturent. La deuxième compte les serveurs retirés de la rotation. La troisième compte les erreurs serveur. Les trois notifient une adresse mail.</a:t>
             </a:r>
             <a:endParaRPr lang="en-US" dirty="0"/>
           </a:p>
@@ -1434,12 +1436,12 @@
           <a:p>
             <a:r>
               <a:rPr lang="en-US" dirty="0"/>
-              <a:t>Troisième question : quand ça casse. On a regardé chaque panne possible, et on a chronométré.
-Un serveur tombe. Le répartiteur l'interroge toutes les quinze secondes ; au bout de deux échecs, donc trente secondes, il arrête de lui envoyer des clients. Et les achats déjà en cours ont trente secondes de plus pour se terminer. Le client ne voit rien : il est servi par les autres.
-Une zone AWS entière tombe — ça arrive, c'est un bâtiment entier. Les serveurs des autres zones prennent le relais. Automatique.
-La base tombe. En production, AWS garde une machine de secours dans une autre zone. La bascule prend une à deux minutes. Il y a quelques secondes d'erreurs, on ne va pas vous mentir, puis ça repart.
-Notre serveur d'entrée tombe : aucun impact client, aucun client ne passe par là.
-Et le point qu'on veut vraiment que vous reteniez : le panier du client est conservé. Les paniers sont sur le disque partagé, pas sur la machine qui tombe. Pour une billetterie, c'est toute la différence.</a:t>
+              <a:t>Troisième question : le comportement en cas de panne. Nous avons mesuré chaque cas.
+Un serveur tombe. Le load balancer le vérifie toutes les quinze secondes. Après deux échecs, soit environ trente secondes, il le retire de la rotation. Les requêtes déjà en cours ont trente secondes supplémentaires pour se terminer. Le client ne voit rien : il est servi par les autres serveurs.
+Une zone de disponibilité tombe. Le load balancer a un nœud par zone, il cesse d'utiliser celui de la zone en panne. Les serveurs des autres zones prennent le relais. Aucune action de notre part.
+La base de données tombe. En production, elle a une instance de secours dans une autre zone. Le basculement prend entre une et deux minutes. Il y a des erreurs pendant ce temps, nous ne le cachons pas, puis le service revient.
+Le bastion tombe. Aucune conséquence pour les clients : il ne sert qu'à l'administration. Il faut le recréer, ce qui prend deux minutes.
+Un point important : le panier du client est conservé. Les sessions PHP sont stockées sur le disque partagé, pas sur le serveur. Si un serveur tombe, le client continue son achat sur un autre.</a:t>
             </a:r>
             <a:endParaRPr lang="en-US" dirty="0"/>
           </a:p>
@@ -1527,13 +1529,13 @@
           <a:p>
             <a:r>
               <a:rPr lang="en-US" dirty="0"/>
-              <a:t>On tenait à vous montrer cette diapo, parce que c'est la partie honnête du projet.
-Le code était écrit, relu, vérifié. Et puis on l'a déployé pour de vrai sur AWS, et on s'est pris quatre murs qu'aucune relecture n'aurait montrés.
-Le premier : AWS n'accepte que certains caractères dans les descriptions. On avait écrit une petite flèche, avec un chevron. Refusé.
-Le deuxième : l'outil en ligne de commande d'AWS n'existe plus dans les dépôts d'Ubuntu 24.04. On aurait pu installer la version officielle — soixante mégaoctets par serveur, pour un seul appel. On est passés à une bibliothèque Python déjà présente.
-Le troisième, c'est notre préféré. Le mot de passe de la base est généré au hasard, et il contenait une esperluette, le « et commercial ». Notre script chargeait le fichier avec une commande du shell — et le shell a pris le mot de passe pour une commande, et a essayé de l'exécuter. Maintenant on lit le fichier sans jamais l'interpréter, et on a limité les caractères du mot de passe.
-Le quatrième : PrestaShop vide son cache après l'installation. Sur un disque partagé en réseau, supprimer un fichier encore ouvert laisse une trace invisible, donc la suppression échouait — et ça tuait le conteneur juste après une installation réussie. On a compris que ce cache n'avait rien à faire sur le disque partagé : c'est un fichier temporaire, propre à chaque serveur. On l'a remis en local.
-Les quatre sont corrigés dans le dépôt. Un déploiement depuis zéro ne les rencontre plus.</a:t>
+              <a:t>Nous présentons cette diapositive parce qu'elle montre ce que le déploiement réel apporte.
+Le code était écrit, relu et vérifié. En le déployant sur un compte AWS, nous avons rencontré quatre erreurs qu'une relecture n'aurait pas montrées.
+Première erreur : AWS n'accepte qu'un jeu de caractères limité dans les descriptions de groupes de sécurité. Nous avions écrit une flèche avec un chevron. La création du groupe a échoué.
+Deuxième erreur : le paquet awscli n'existe plus dans les dépôts d'Ubuntu 24.04. Installer la version officielle représentait soixante mégaoctets par serveur pour un seul appel. Nous l'avons remplacé par la bibliothèque Python boto3, déjà disponible.
+Troisième erreur : notre script chargeait le fichier de configuration avec la commande source du shell. Le mot de passe de la base, généré aléatoirement, contenait une esperluette. Le shell l'a interprétée comme un séparateur de commande. Nous lisons maintenant ce fichier sans l'interpréter, et nous avons restreint les caractères du mot de passe généré.
+Quatrième erreur : sur un disque réseau, supprimer un fichier encore ouvert laisse une entrée temporaire. Le vidage de cache de PrestaShop échouait donc après l'installation, et arrêtait le conteneur. Nous avons déplacé ce cache sur le disque local de chaque serveur, puisqu'il est propre à chaque serveur et régénérable.
+Les quatre corrections sont dans le dépôt.</a:t>
             </a:r>
             <a:endParaRPr lang="en-US" dirty="0"/>
           </a:p>
@@ -2017,27 +2019,24 @@
         </p:nvSpPr>
         <p:spPr>
           <a:xfrm>
-            <a:off x="566928" y="2971800"/>
-            <a:ext cx="8778240" cy="822960"/>
-          </a:xfrm>
-          <a:prstGeom prst="rect">
-            <a:avLst/>
-          </a:prstGeom>
-          <a:noFill/>
-          <a:ln/>
-        </p:spPr>
-        <p:txBody>
-          <a:bodyPr wrap="square" lIns="0" tIns="0" rIns="0" bIns="0" rtlCol="0" anchor="ctr"/>
-          <a:lstStyle/>
-          <a:p>
-            <a:pPr indent="0" marL="0">
-              <a:lnSpc>
-                <a:spcPts val="2800"/>
-              </a:lnSpc>
-              <a:buNone/>
-            </a:pPr>
-            <a:r>
-              <a:rPr lang="en-US" sz="2100" dirty="0">
+            <a:off x="566928" y="3017520"/>
+            <a:ext cx="8778240" cy="457200"/>
+          </a:xfrm>
+          <a:prstGeom prst="rect">
+            <a:avLst/>
+          </a:prstGeom>
+          <a:noFill/>
+          <a:ln/>
+        </p:spPr>
+        <p:txBody>
+          <a:bodyPr wrap="square" lIns="0" tIns="0" rIns="0" bIns="0" rtlCol="0" anchor="ctr"/>
+          <a:lstStyle/>
+          <a:p>
+            <a:pPr indent="0" marL="0">
+              <a:buNone/>
+            </a:pPr>
+            <a:r>
+              <a:rPr lang="en-US" sz="2200" dirty="0">
                 <a:solidFill>
                   <a:srgbClr val="A8B8C8"/>
                 </a:solidFill>
@@ -2045,29 +2044,9 @@
                 <a:ea typeface="Calibri" pitchFamily="34" charset="-122"/>
                 <a:cs typeface="Calibri" pitchFamily="34" charset="-120"/>
               </a:rPr>
-              <a:t>Une boutique de billets qui tient debout</a:t>
-            </a:r>
-            <a:endParaRPr lang="en-US" sz="2100" dirty="0"/>
-          </a:p>
-          <a:p>
-            <a:pPr indent="0" marL="0">
-              <a:lnSpc>
-                <a:spcPts val="2800"/>
-              </a:lnSpc>
-              <a:buNone/>
-            </a:pPr>
-            <a:r>
-              <a:rPr lang="en-US" sz="2100" dirty="0">
-                <a:solidFill>
-                  <a:srgbClr val="A8B8C8"/>
-                </a:solidFill>
-                <a:latin typeface="Calibri" pitchFamily="34" charset="0"/>
-                <a:ea typeface="Calibri" pitchFamily="34" charset="-122"/>
-                <a:cs typeface="Calibri" pitchFamily="34" charset="-120"/>
-              </a:rPr>
-              <a:t>le jour de l'ouverture des ventes</a:t>
-            </a:r>
-            <a:endParaRPr lang="en-US" sz="2100" dirty="0"/>
+              <a:t>Infrastructure de la boutique de billets</a:t>
+            </a:r>
+            <a:endParaRPr lang="en-US" sz="2200" dirty="0"/>
           </a:p>
         </p:txBody>
       </p:sp>
@@ -2079,7 +2058,7 @@
         </p:nvSpPr>
         <p:spPr>
           <a:xfrm>
-            <a:off x="566928" y="4114800"/>
+            <a:off x="566928" y="3840480"/>
             <a:ext cx="1645920" cy="411480"/>
           </a:xfrm>
           <a:prstGeom prst="roundRect">
@@ -2106,7 +2085,7 @@
         </p:nvSpPr>
         <p:spPr>
           <a:xfrm>
-            <a:off x="566928" y="4114800"/>
+            <a:off x="566928" y="3840480"/>
             <a:ext cx="1645920" cy="411480"/>
           </a:xfrm>
           <a:prstGeom prst="rect">
@@ -2145,7 +2124,7 @@
         </p:nvSpPr>
         <p:spPr>
           <a:xfrm>
-            <a:off x="2395728" y="4114800"/>
+            <a:off x="2395728" y="3840480"/>
             <a:ext cx="1645920" cy="411480"/>
           </a:xfrm>
           <a:prstGeom prst="roundRect">
@@ -2172,7 +2151,7 @@
         </p:nvSpPr>
         <p:spPr>
           <a:xfrm>
-            <a:off x="2395728" y="4114800"/>
+            <a:off x="2395728" y="3840480"/>
             <a:ext cx="1645920" cy="411480"/>
           </a:xfrm>
           <a:prstGeom prst="rect">
@@ -2211,7 +2190,7 @@
         </p:nvSpPr>
         <p:spPr>
           <a:xfrm>
-            <a:off x="4224528" y="4114800"/>
+            <a:off x="4224528" y="3840480"/>
             <a:ext cx="1645920" cy="411480"/>
           </a:xfrm>
           <a:prstGeom prst="roundRect">
@@ -2238,7 +2217,7 @@
         </p:nvSpPr>
         <p:spPr>
           <a:xfrm>
-            <a:off x="4224528" y="4114800"/>
+            <a:off x="4224528" y="3840480"/>
             <a:ext cx="1645920" cy="411480"/>
           </a:xfrm>
           <a:prstGeom prst="rect">
@@ -2277,7 +2256,7 @@
         </p:nvSpPr>
         <p:spPr>
           <a:xfrm>
-            <a:off x="6053328" y="4114800"/>
+            <a:off x="6053328" y="3840480"/>
             <a:ext cx="1645920" cy="411480"/>
           </a:xfrm>
           <a:prstGeom prst="roundRect">
@@ -2304,7 +2283,7 @@
         </p:nvSpPr>
         <p:spPr>
           <a:xfrm>
-            <a:off x="6053328" y="4114800"/>
+            <a:off x="6053328" y="3840480"/>
             <a:ext cx="1645920" cy="411480"/>
           </a:xfrm>
           <a:prstGeom prst="rect">
@@ -2343,7 +2322,7 @@
         </p:nvSpPr>
         <p:spPr>
           <a:xfrm>
-            <a:off x="566928" y="5029200"/>
+            <a:off x="566928" y="4800600"/>
             <a:ext cx="11055096" cy="320040"/>
           </a:xfrm>
           <a:prstGeom prst="rect">
@@ -2382,7 +2361,7 @@
         </p:nvSpPr>
         <p:spPr>
           <a:xfrm>
-            <a:off x="566928" y="5394960"/>
+            <a:off x="566928" y="5193792"/>
             <a:ext cx="11055096" cy="274320"/>
           </a:xfrm>
           <a:prstGeom prst="rect">
@@ -2407,7 +2386,7 @@
                 <a:ea typeface="Calibri" pitchFamily="34" charset="-122"/>
                 <a:cs typeface="Calibri" pitchFamily="34" charset="-120"/>
               </a:rPr>
-              <a:t>En ligne sur un vrai compte AWS, région Paris</a:t>
+              <a:t>Déployé sur un compte AWS, région eu-west-3 (Paris)</a:t>
             </a:r>
             <a:endParaRPr lang="en-US" sz="1300" dirty="0"/>
           </a:p>
@@ -2471,7 +2450,7 @@
                 <a:ea typeface="Courier New" pitchFamily="34" charset="-122"/>
                 <a:cs typeface="Courier New" pitchFamily="34" charset="-120"/>
               </a:rPr>
-              <a:t>09 — CE QU'ON N'A PAS FAIT</a:t>
+              <a:t>09 — LIMITES</a:t>
             </a:r>
             <a:endParaRPr lang="en-US" sz="1100" dirty="0"/>
           </a:p>
@@ -2510,7 +2489,7 @@
                 <a:ea typeface="Arial" pitchFamily="34" charset="-122"/>
                 <a:cs typeface="Arial" pitchFamily="34" charset="-120"/>
               </a:rPr>
-              <a:t>Nos limites, et comment on les franchirait</a:t>
+              <a:t>Limites de la solution</a:t>
             </a:r>
             <a:endParaRPr lang="en-US" sz="3000" dirty="0"/>
           </a:p>
@@ -2576,7 +2555,7 @@
                 <a:ea typeface="Arial" pitchFamily="34" charset="-122"/>
                 <a:cs typeface="Arial" pitchFamily="34" charset="-120"/>
               </a:rPr>
-              <a:t>Ajouter des serveurs demande quelqu'un</a:t>
+              <a:t>La montée en charge n'est pas automatique</a:t>
             </a:r>
             <a:endParaRPr lang="en-US" sz="1400" dirty="0"/>
           </a:p>
@@ -2615,7 +2594,7 @@
                 <a:ea typeface="Calibri" pitchFamily="34" charset="-122"/>
                 <a:cs typeface="Calibri" pitchFamily="34" charset="-120"/>
               </a:rPr>
-              <a:t>Ce n'est pas automatique : il faut un opérateur et deux commandes, environ 3 minutes. Pour l'automatiser, il faudrait préparer une image toute faite du serveur. Notre installation est déjà écrite pour ça.</a:t>
+              <a:t>Elle demande un opérateur et deux commandes, environ 3 minutes. Pour l'automatiser, il faudrait construire une image serveur préconfigurée avec Packer et utiliser un groupe d'autoscaling.</a:t>
             </a:r>
             <a:endParaRPr lang="en-US" sz="1150" dirty="0"/>
           </a:p>
@@ -2681,7 +2660,7 @@
                 <a:ea typeface="Arial" pitchFamily="34" charset="-122"/>
                 <a:cs typeface="Arial" pitchFamily="34" charset="-120"/>
               </a:rPr>
-              <a:t>Tout le site est sur le disque partagé</a:t>
+              <a:t>Le site entier est sur le disque partagé</a:t>
             </a:r>
             <a:endParaRPr lang="en-US" sz="1400" dirty="0"/>
           </a:p>
@@ -2720,7 +2699,7 @@
                 <a:ea typeface="Calibri" pitchFamily="34" charset="-122"/>
                 <a:cs typeface="Calibri" pitchFamily="34" charset="-120"/>
               </a:rPr>
-              <a:t>C'est pratique — les serveurs sont interchangeables — mais un disque réseau est plus lent qu'un disque local. Au-delà de quelques milliers de visiteurs par minute, il faudrait mettre le site dans l'image et ne partager que les photos.</a:t>
+              <a:t>Cela rend les serveurs interchangeables, mais un disque réseau est plus lent qu'un disque local. Au-delà de quelques milliers de requêtes par minute, il faudrait mettre le code dans l'image et ne partager que les images produits.</a:t>
             </a:r>
             <a:endParaRPr lang="en-US" sz="1150" dirty="0"/>
           </a:p>
@@ -2786,7 +2765,7 @@
                 <a:ea typeface="Arial" pitchFamily="34" charset="-122"/>
                 <a:cs typeface="Arial" pitchFamily="34" charset="-120"/>
               </a:rPr>
-              <a:t>Une seule base pour écrire</a:t>
+              <a:t>Une seule base en écriture</a:t>
             </a:r>
             <a:endParaRPr lang="en-US" sz="1400" dirty="0"/>
           </a:p>
@@ -2825,7 +2804,7 @@
                 <a:ea typeface="Calibri" pitchFamily="34" charset="-122"/>
                 <a:cs typeface="Calibri" pitchFamily="34" charset="-120"/>
               </a:rPr>
-              <a:t>On peut ajouter des copies pour la lecture, mais pas pour l'écriture. Et une billetterie, ça écrit beaucoup. C'est la taille de cette base qui est notre vrai plafond.</a:t>
+              <a:t>Les lectures peuvent être réparties sur des réplicas, pas les écritures. Une billetterie écrit beaucoup : la taille de l'instance principale est la limite.</a:t>
             </a:r>
             <a:endParaRPr lang="en-US" sz="1150" dirty="0"/>
           </a:p>
@@ -2930,7 +2909,7 @@
                 <a:ea typeface="Calibri" pitchFamily="34" charset="-122"/>
                 <a:cs typeface="Calibri" pitchFamily="34" charset="-120"/>
               </a:rPr>
-              <a:t>Si toute la région Paris tombe, la boutique tombe. Doubler dans une autre région coûterait plus cher que la panne qu'on évite. C'est un choix, pas un oubli.</a:t>
+              <a:t>Une panne régionale interrompt le service. Le multi-région coûterait plus que la panne qu'il évite à cette échelle.</a:t>
             </a:r>
             <a:endParaRPr lang="en-US" sz="1150" dirty="0"/>
           </a:p>
@@ -3033,7 +3012,7 @@
                 <a:ea typeface="Arial" pitchFamily="34" charset="-122"/>
                 <a:cs typeface="Arial" pitchFamily="34" charset="-120"/>
               </a:rPr>
-              <a:t>D'un compte AWS vide à une boutique en ligne</a:t>
+              <a:t>Déploiement complet en six commandes</a:t>
             </a:r>
             <a:endParaRPr lang="en-US" sz="3000" dirty="0"/>
           </a:p>
@@ -3102,7 +3081,7 @@
                 <a:ea typeface="Courier New" pitchFamily="34" charset="-122"/>
                 <a:cs typeface="Courier New" pitchFamily="34" charset="-120"/>
               </a:rPr>
-              <a:t>./scripts/bootstrap-backend.sh dev     # une seule fois par compte</a:t>
+              <a:t>./scripts/bootstrap-backend.sh dev     # une fois par compte AWS</a:t>
             </a:r>
             <a:endParaRPr lang="en-US" sz="1150" dirty="0"/>
           </a:p>
@@ -3151,7 +3130,7 @@
                 <a:ea typeface="Courier New" pitchFamily="34" charset="-122"/>
                 <a:cs typeface="Courier New" pitchFamily="34" charset="-120"/>
               </a:rPr>
-              <a:t>terraform -chdir=terraform apply       # ~12 min (la base est lente)</a:t>
+              <a:t>terraform -chdir=terraform apply       # ~12 min (création RDS)</a:t>
             </a:r>
             <a:endParaRPr lang="en-US" sz="1150" dirty="0"/>
           </a:p>
@@ -3323,7 +3302,7 @@
                 <a:ea typeface="Calibri" pitchFamily="34" charset="-122"/>
                 <a:cs typeface="Calibri" pitchFamily="34" charset="-120"/>
               </a:rPr>
-              <a:t>La boutique, puis l'administration</a:t>
+              <a:t>La boutique et le back-office</a:t>
             </a:r>
             <a:endParaRPr lang="en-US" sz="1350" dirty="0"/>
           </a:p>
@@ -3426,7 +3405,7 @@
                 <a:ea typeface="Calibri" pitchFamily="34" charset="-122"/>
                 <a:cs typeface="Calibri" pitchFamily="34" charset="-120"/>
               </a:rPr>
-              <a:t>On relance l'installation : changed=0</a:t>
+              <a:t>Playbook relancé : changed=0</a:t>
             </a:r>
             <a:endParaRPr lang="en-US" sz="1350" dirty="0"/>
           </a:p>
@@ -3529,7 +3508,7 @@
                 <a:ea typeface="Calibri" pitchFamily="34" charset="-122"/>
                 <a:cs typeface="Calibri" pitchFamily="34" charset="-120"/>
               </a:rPr>
-              <a:t>On ajoute un serveur, il entre tout seul</a:t>
+              <a:t>Ajout d'un serveur</a:t>
             </a:r>
             <a:endParaRPr lang="en-US" sz="1350" dirty="0"/>
           </a:p>
@@ -3632,7 +3611,7 @@
                 <a:ea typeface="Calibri" pitchFamily="34" charset="-122"/>
                 <a:cs typeface="Calibri" pitchFamily="34" charset="-120"/>
               </a:rPr>
-              <a:t>On en coupe un : la boutique tient</a:t>
+              <a:t>Arrêt d'un serveur : le site répond</a:t>
             </a:r>
             <a:endParaRPr lang="en-US" sz="1350" dirty="0"/>
           </a:p>
@@ -3673,8 +3652,8 @@
         </p:nvSpPr>
         <p:spPr>
           <a:xfrm>
-            <a:off x="795528" y="4663440"/>
-            <a:ext cx="6217920" cy="548640"/>
+            <a:off x="795528" y="4709160"/>
+            <a:ext cx="6217920" cy="457200"/>
           </a:xfrm>
           <a:prstGeom prst="rect">
             <a:avLst/>
@@ -3698,7 +3677,7 @@
                 <a:ea typeface="Calibri" pitchFamily="34" charset="-122"/>
                 <a:cs typeface="Calibri" pitchFamily="34" charset="-120"/>
               </a:rPr>
-              <a:t>Tout le reste — réseau, base, disque, surveillance, mots de passe — découle de ces six commandes.</a:t>
+              <a:t>Réseau, base, stockage, surveillance et secrets sont créés par ces commandes.</a:t>
             </a:r>
             <a:endParaRPr lang="en-US" sz="1250" dirty="0"/>
           </a:p>
@@ -3794,7 +3773,7 @@
                 <a:ea typeface="Courier New" pitchFamily="34" charset="-122"/>
                 <a:cs typeface="Courier New" pitchFamily="34" charset="-120"/>
               </a:rPr>
-              <a:t>MERCI — VOS QUESTIONS</a:t>
+              <a:t>CONCLUSION</a:t>
             </a:r>
             <a:endParaRPr lang="en-US" sz="1200" dirty="0"/>
           </a:p>
@@ -3836,7 +3815,7 @@
                 <a:ea typeface="Arial" pitchFamily="34" charset="-122"/>
                 <a:cs typeface="Arial" pitchFamily="34" charset="-120"/>
               </a:rPr>
-              <a:t>En ligne, documentée,</a:t>
+              <a:t>Déployée, documentée,</a:t>
             </a:r>
             <a:endParaRPr lang="en-US" sz="4200" dirty="0"/>
           </a:p>
@@ -3856,7 +3835,7 @@
                 <a:ea typeface="Arial" pitchFamily="34" charset="-122"/>
                 <a:cs typeface="Arial" pitchFamily="34" charset="-120"/>
               </a:rPr>
-              <a:t>et on sait la refaire.</a:t>
+              <a:t>reproductible.</a:t>
             </a:r>
             <a:endParaRPr lang="en-US" sz="4200" dirty="0"/>
           </a:p>
@@ -3961,7 +3940,7 @@
                 <a:ea typeface="Calibri" pitchFamily="34" charset="-122"/>
                 <a:cs typeface="Calibri" pitchFamily="34" charset="-120"/>
               </a:rPr>
-              <a:t>6 briques · 3 environnements</a:t>
+              <a:t>6 modules · 3 environnements · état distant</a:t>
             </a:r>
             <a:endParaRPr lang="en-US" sz="1150" dirty="0"/>
           </a:p>
@@ -4066,7 +4045,7 @@
                 <a:ea typeface="Calibri" pitchFamily="34" charset="-122"/>
                 <a:cs typeface="Calibri" pitchFamily="34" charset="-120"/>
               </a:rPr>
-              <a:t>3 rôles · secrets chiffrés · changed=0</a:t>
+              <a:t>3 rôles · Galaxy · Vault · changed=0</a:t>
             </a:r>
             <a:endParaRPr lang="en-US" sz="1150" dirty="0"/>
           </a:p>
@@ -4171,7 +4150,7 @@
                 <a:ea typeface="Calibri" pitchFamily="34" charset="-122"/>
                 <a:cs typeface="Calibri" pitchFamily="34" charset="-120"/>
               </a:rPr>
-              <a:t>installer, exploiter, dépanner</a:t>
+              <a:t>déployer, exploiter, dépanner</a:t>
             </a:r>
             <a:endParaRPr lang="en-US" sz="1150" dirty="0"/>
           </a:p>
@@ -4210,7 +4189,7 @@
                 <a:ea typeface="Arial" pitchFamily="34" charset="-122"/>
                 <a:cs typeface="Arial" pitchFamily="34" charset="-120"/>
               </a:rPr>
-              <a:t>5HASH  —  merci de votre attention</a:t>
+              <a:t>Merci de votre attention. Nous répondons à vos questions.</a:t>
             </a:r>
             <a:endParaRPr lang="en-US" sz="1700" dirty="0"/>
           </a:p>
@@ -4313,7 +4292,7 @@
                 <a:ea typeface="Arial" pitchFamily="34" charset="-122"/>
                 <a:cs typeface="Arial" pitchFamily="34" charset="-120"/>
               </a:rPr>
-              <a:t>On s'est posé trois questions simples</a:t>
+              <a:t>Trois questions au départ</a:t>
             </a:r>
             <a:endParaRPr lang="en-US" sz="3000" dirty="0"/>
           </a:p>
@@ -4446,7 +4425,7 @@
                 <a:ea typeface="Arial" pitchFamily="34" charset="-122"/>
                 <a:cs typeface="Arial" pitchFamily="34" charset="-120"/>
               </a:rPr>
-              <a:t>Comment un client arrive</a:t>
+              <a:t>Par où passent</a:t>
             </a:r>
             <a:endParaRPr lang="en-US" sz="1600" dirty="0"/>
           </a:p>
@@ -4466,7 +4445,7 @@
                 <a:ea typeface="Arial" pitchFamily="34" charset="-122"/>
                 <a:cs typeface="Arial" pitchFamily="34" charset="-120"/>
               </a:rPr>
-              <a:t>jusqu'à la boutique ?</a:t>
+              <a:t>les requêtes ?</a:t>
             </a:r>
             <a:endParaRPr lang="en-US" sz="1600" dirty="0"/>
           </a:p>
@@ -4505,7 +4484,7 @@
                 <a:ea typeface="Calibri" pitchFamily="34" charset="-122"/>
                 <a:cs typeface="Calibri" pitchFamily="34" charset="-120"/>
               </a:rPr>
-              <a:t>Une seule porte ouverte sur Internet. Tout le reste est caché derrière.</a:t>
+              <a:t>Un seul point d'entrée public. Les serveurs et la base sont dans des réseaux privés.</a:t>
             </a:r>
             <a:endParaRPr lang="en-US" sz="1350" dirty="0"/>
           </a:p>
@@ -4638,7 +4617,7 @@
                 <a:ea typeface="Arial" pitchFamily="34" charset="-122"/>
                 <a:cs typeface="Arial" pitchFamily="34" charset="-120"/>
               </a:rPr>
-              <a:t>Et si dix fois plus</a:t>
+              <a:t>Comment absorber</a:t>
             </a:r>
             <a:endParaRPr lang="en-US" sz="1600" dirty="0"/>
           </a:p>
@@ -4658,7 +4637,7 @@
                 <a:ea typeface="Arial" pitchFamily="34" charset="-122"/>
                 <a:cs typeface="Arial" pitchFamily="34" charset="-120"/>
               </a:rPr>
-              <a:t>de monde arrive ?</a:t>
+              <a:t>un pic de trafic ?</a:t>
             </a:r>
             <a:endParaRPr lang="en-US" sz="1600" dirty="0"/>
           </a:p>
@@ -4697,7 +4676,7 @@
                 <a:ea typeface="Calibri" pitchFamily="34" charset="-122"/>
                 <a:cs typeface="Calibri" pitchFamily="34" charset="-120"/>
               </a:rPr>
-              <a:t>Nos serveurs ne gardent rien. Donc en ajouter, c'est changer un chiffre.</a:t>
+              <a:t>Les serveurs ne stockent aucune donnée. On peut donc en ajouter à la demande.</a:t>
             </a:r>
             <a:endParaRPr lang="en-US" sz="1350" dirty="0"/>
           </a:p>
@@ -4830,7 +4809,7 @@
                 <a:ea typeface="Arial" pitchFamily="34" charset="-122"/>
                 <a:cs typeface="Arial" pitchFamily="34" charset="-120"/>
               </a:rPr>
-              <a:t>Et si une machine</a:t>
+              <a:t>Que se passe-t-il</a:t>
             </a:r>
             <a:endParaRPr lang="en-US" sz="1600" dirty="0"/>
           </a:p>
@@ -4850,7 +4829,7 @@
                 <a:ea typeface="Arial" pitchFamily="34" charset="-122"/>
                 <a:cs typeface="Arial" pitchFamily="34" charset="-120"/>
               </a:rPr>
-              <a:t>tombe en panne ?</a:t>
+              <a:t>en cas de panne ?</a:t>
             </a:r>
             <a:endParaRPr lang="en-US" sz="1600" dirty="0"/>
           </a:p>
@@ -4889,7 +4868,7 @@
                 <a:ea typeface="Calibri" pitchFamily="34" charset="-122"/>
                 <a:cs typeface="Calibri" pitchFamily="34" charset="-120"/>
               </a:rPr>
-              <a:t>On l'a mesuré : le client ne voit rien, et son panier est conservé.</a:t>
+              <a:t>Le load balancer retire le serveur en panne. Les autres continuent de répondre.</a:t>
             </a:r>
             <a:endParaRPr lang="en-US" sz="1350" dirty="0"/>
           </a:p>
@@ -4920,7 +4899,7 @@
               <a:buNone/>
             </a:pPr>
             <a:r>
-              <a:rPr lang="en-US" sz="1500" i="1" dirty="0">
+              <a:rPr lang="en-US" sz="1500" b="1" dirty="0">
                 <a:solidFill>
                   <a:srgbClr val="9E5D06"/>
                 </a:solidFill>
@@ -4928,7 +4907,7 @@
                 <a:ea typeface="Calibri" pitchFamily="34" charset="-122"/>
                 <a:cs typeface="Calibri" pitchFamily="34" charset="-120"/>
               </a:rPr>
-              <a:t>Chaque choix qu'on va vous présenter répond à l'une de ces trois questions.</a:t>
+              <a:t>Chaque choix présenté ensuite répond à l'une de ces trois questions.</a:t>
             </a:r>
             <a:endParaRPr lang="en-US" sz="1500" dirty="0"/>
           </a:p>
@@ -4992,7 +4971,7 @@
                 <a:ea typeface="Courier New" pitchFamily="34" charset="-122"/>
                 <a:cs typeface="Courier New" pitchFamily="34" charset="-120"/>
               </a:rPr>
-              <a:t>02 — L'ARCHITECTURE</a:t>
+              <a:t>02 — ARCHITECTURE</a:t>
             </a:r>
             <a:endParaRPr lang="en-US" sz="1100" dirty="0"/>
           </a:p>
@@ -5031,7 +5010,7 @@
                 <a:ea typeface="Arial" pitchFamily="34" charset="-122"/>
                 <a:cs typeface="Arial" pitchFamily="34" charset="-120"/>
               </a:rPr>
-              <a:t>Une entrée, des caisses, un coffre</a:t>
+              <a:t>Trois niveaux de réseau, deux zones de disponibilité</a:t>
             </a:r>
             <a:endParaRPr lang="en-US" sz="3000" dirty="0"/>
           </a:p>
@@ -5045,8 +5024,8 @@
         </p:nvSpPr>
         <p:spPr>
           <a:xfrm>
-            <a:off x="1417320" y="1956816"/>
-            <a:ext cx="10149840" cy="1051560"/>
+            <a:off x="1600200" y="1956816"/>
+            <a:ext cx="9966960" cy="1051560"/>
           </a:xfrm>
           <a:prstGeom prst="roundRect">
             <a:avLst>
@@ -5073,7 +5052,7 @@
         <p:spPr>
           <a:xfrm>
             <a:off x="521208" y="2208276"/>
-            <a:ext cx="868680" cy="548640"/>
+            <a:ext cx="1051560" cy="548640"/>
           </a:xfrm>
           <a:prstGeom prst="rect">
             <a:avLst/>
@@ -5097,7 +5076,7 @@
                 <a:ea typeface="Courier New" pitchFamily="34" charset="-122"/>
                 <a:cs typeface="Courier New" pitchFamily="34" charset="-120"/>
               </a:rPr>
-              <a:t>CÔTÉ RUE</a:t>
+              <a:t>RÉSEAU</a:t>
             </a:r>
             <a:endParaRPr lang="en-US" sz="850" dirty="0"/>
           </a:p>
@@ -5114,7 +5093,7 @@
                 <a:ea typeface="Courier New" pitchFamily="34" charset="-122"/>
                 <a:cs typeface="Courier New" pitchFamily="34" charset="-120"/>
               </a:rPr>
-              <a:t>(public)</a:t>
+              <a:t>PUBLIC</a:t>
             </a:r>
             <a:endParaRPr lang="en-US" sz="850" dirty="0"/>
           </a:p>
@@ -5128,8 +5107,8 @@
         </p:nvSpPr>
         <p:spPr>
           <a:xfrm>
-            <a:off x="1417320" y="3355848"/>
-            <a:ext cx="10149840" cy="1051560"/>
+            <a:off x="1600200" y="3355848"/>
+            <a:ext cx="9966960" cy="1051560"/>
           </a:xfrm>
           <a:prstGeom prst="roundRect">
             <a:avLst>
@@ -5156,7 +5135,7 @@
         <p:spPr>
           <a:xfrm>
             <a:off x="521208" y="3607308"/>
-            <a:ext cx="868680" cy="548640"/>
+            <a:ext cx="1051560" cy="548640"/>
           </a:xfrm>
           <a:prstGeom prst="rect">
             <a:avLst/>
@@ -5180,7 +5159,7 @@
                 <a:ea typeface="Courier New" pitchFamily="34" charset="-122"/>
                 <a:cs typeface="Courier New" pitchFamily="34" charset="-120"/>
               </a:rPr>
-              <a:t>LES CAISSES</a:t>
+              <a:t>RÉSEAU PRIVÉ</a:t>
             </a:r>
             <a:endParaRPr lang="en-US" sz="850" dirty="0"/>
           </a:p>
@@ -5197,7 +5176,7 @@
                 <a:ea typeface="Courier New" pitchFamily="34" charset="-122"/>
                 <a:cs typeface="Courier New" pitchFamily="34" charset="-120"/>
               </a:rPr>
-              <a:t>(privé)</a:t>
+              <a:t>APPLICATION</a:t>
             </a:r>
             <a:endParaRPr lang="en-US" sz="850" dirty="0"/>
           </a:p>
@@ -5211,8 +5190,8 @@
         </p:nvSpPr>
         <p:spPr>
           <a:xfrm>
-            <a:off x="1417320" y="4727448"/>
-            <a:ext cx="10149840" cy="1188720"/>
+            <a:off x="1600200" y="4727448"/>
+            <a:ext cx="9966960" cy="1188720"/>
           </a:xfrm>
           <a:prstGeom prst="roundRect">
             <a:avLst>
@@ -5239,7 +5218,7 @@
         <p:spPr>
           <a:xfrm>
             <a:off x="521208" y="5047488"/>
-            <a:ext cx="868680" cy="548640"/>
+            <a:ext cx="1051560" cy="548640"/>
           </a:xfrm>
           <a:prstGeom prst="rect">
             <a:avLst/>
@@ -5263,7 +5242,7 @@
                 <a:ea typeface="Courier New" pitchFamily="34" charset="-122"/>
                 <a:cs typeface="Courier New" pitchFamily="34" charset="-120"/>
               </a:rPr>
-              <a:t>LES RÉSERVES</a:t>
+              <a:t>RÉSEAU PRIVÉ</a:t>
             </a:r>
             <a:endParaRPr lang="en-US" sz="850" dirty="0"/>
           </a:p>
@@ -5280,7 +5259,7 @@
                 <a:ea typeface="Courier New" pitchFamily="34" charset="-122"/>
                 <a:cs typeface="Courier New" pitchFamily="34" charset="-120"/>
               </a:rPr>
-              <a:t>(privé)</a:t>
+              <a:t>DONNÉES</a:t>
             </a:r>
             <a:endParaRPr lang="en-US" sz="850" dirty="0"/>
           </a:p>
@@ -5294,7 +5273,7 @@
         </p:nvSpPr>
         <p:spPr>
           <a:xfrm>
-            <a:off x="1691640" y="1554480"/>
+            <a:off x="1874520" y="1554480"/>
             <a:ext cx="1828800" cy="274320"/>
           </a:xfrm>
           <a:prstGeom prst="rect">
@@ -5319,7 +5298,7 @@
                 <a:ea typeface="Courier New" pitchFamily="34" charset="-122"/>
                 <a:cs typeface="Courier New" pitchFamily="34" charset="-120"/>
               </a:rPr>
-              <a:t>LES CLIENTS</a:t>
+              <a:t>INTERNET</a:t>
             </a:r>
             <a:endParaRPr lang="en-US" sz="1000" dirty="0"/>
           </a:p>
@@ -5333,7 +5312,7 @@
         </p:nvSpPr>
         <p:spPr>
           <a:xfrm>
-            <a:off x="2103120" y="1810512"/>
+            <a:off x="2286000" y="1810512"/>
             <a:ext cx="0" cy="146304"/>
           </a:xfrm>
           <a:prstGeom prst="line">
@@ -5356,8 +5335,8 @@
         </p:nvSpPr>
         <p:spPr>
           <a:xfrm>
-            <a:off x="2286000" y="1737360"/>
-            <a:ext cx="1097280" cy="228600"/>
+            <a:off x="2468880" y="1737360"/>
+            <a:ext cx="1463040" cy="228600"/>
           </a:xfrm>
           <a:prstGeom prst="rect">
             <a:avLst/>
@@ -5381,7 +5360,7 @@
                 <a:ea typeface="Courier New" pitchFamily="34" charset="-122"/>
                 <a:cs typeface="Courier New" pitchFamily="34" charset="-120"/>
               </a:rPr>
-              <a:t>le site</a:t>
+              <a:t>clients · HTTP</a:t>
             </a:r>
             <a:endParaRPr lang="en-US" sz="850" dirty="0"/>
           </a:p>
@@ -5419,7 +5398,7 @@
         <p:spPr>
           <a:xfrm>
             <a:off x="9464040" y="1737360"/>
-            <a:ext cx="2194560" cy="228600"/>
+            <a:ext cx="2377440" cy="228600"/>
           </a:xfrm>
           <a:prstGeom prst="rect">
             <a:avLst/>
@@ -5443,7 +5422,7 @@
                 <a:ea typeface="Courier New" pitchFamily="34" charset="-122"/>
                 <a:cs typeface="Courier New" pitchFamily="34" charset="-120"/>
               </a:rPr>
-              <a:t>nous, pour installer</a:t>
+              <a:t>administration · SSH, notre IP</a:t>
             </a:r>
             <a:endParaRPr lang="en-US" sz="850" dirty="0"/>
           </a:p>
@@ -5457,8 +5436,8 @@
         </p:nvSpPr>
         <p:spPr>
           <a:xfrm>
-            <a:off x="1673352" y="2103120"/>
-            <a:ext cx="4663440" cy="749808"/>
+            <a:off x="1856232" y="2103120"/>
+            <a:ext cx="4572000" cy="749808"/>
           </a:xfrm>
           <a:prstGeom prst="roundRect">
             <a:avLst>
@@ -5484,24 +5463,24 @@
         </p:nvSpPr>
         <p:spPr>
           <a:xfrm>
-            <a:off x="1828800" y="2194560"/>
-            <a:ext cx="4389120" cy="274320"/>
-          </a:xfrm>
-          <a:prstGeom prst="rect">
-            <a:avLst/>
-          </a:prstGeom>
-          <a:noFill/>
-          <a:ln/>
-        </p:spPr>
-        <p:txBody>
-          <a:bodyPr wrap="square" lIns="0" tIns="0" rIns="0" bIns="0" rtlCol="0" anchor="ctr"/>
-          <a:lstStyle/>
-          <a:p>
-            <a:pPr indent="0" marL="0">
-              <a:buNone/>
-            </a:pPr>
-            <a:r>
-              <a:rPr lang="en-US" sz="1300" b="1" dirty="0">
+            <a:off x="2011680" y="2194560"/>
+            <a:ext cx="4297680" cy="274320"/>
+          </a:xfrm>
+          <a:prstGeom prst="rect">
+            <a:avLst/>
+          </a:prstGeom>
+          <a:noFill/>
+          <a:ln/>
+        </p:spPr>
+        <p:txBody>
+          <a:bodyPr wrap="square" lIns="0" tIns="0" rIns="0" bIns="0" rtlCol="0" anchor="ctr"/>
+          <a:lstStyle/>
+          <a:p>
+            <a:pPr indent="0" marL="0">
+              <a:buNone/>
+            </a:pPr>
+            <a:r>
+              <a:rPr lang="en-US" sz="1350" b="1" dirty="0">
                 <a:solidFill>
                   <a:srgbClr val="17222C"/>
                 </a:solidFill>
@@ -5509,9 +5488,9 @@
                 <a:ea typeface="Arial" pitchFamily="34" charset="-122"/>
                 <a:cs typeface="Arial" pitchFamily="34" charset="-120"/>
               </a:rPr>
-              <a:t>Le répartiteur  (load balancer)</a:t>
-            </a:r>
-            <a:endParaRPr lang="en-US" sz="1300" dirty="0"/>
+              <a:t>Load balancer</a:t>
+            </a:r>
+            <a:endParaRPr lang="en-US" sz="1350" dirty="0"/>
           </a:p>
         </p:txBody>
       </p:sp>
@@ -5523,8 +5502,8 @@
         </p:nvSpPr>
         <p:spPr>
           <a:xfrm>
-            <a:off x="1828800" y="2487168"/>
-            <a:ext cx="4389120" cy="274320"/>
+            <a:off x="2011680" y="2487168"/>
+            <a:ext cx="4297680" cy="274320"/>
           </a:xfrm>
           <a:prstGeom prst="rect">
             <a:avLst/>
@@ -5548,7 +5527,7 @@
                 <a:ea typeface="Calibri" pitchFamily="34" charset="-122"/>
                 <a:cs typeface="Calibri" pitchFamily="34" charset="-120"/>
               </a:rPr>
-              <a:t>il envoie chaque visiteur vers une caisse qui va bien</a:t>
+              <a:t>répartit les requêtes · vérifie chaque serveur toutes les 15 s</a:t>
             </a:r>
             <a:endParaRPr lang="en-US" sz="1100" dirty="0"/>
           </a:p>
@@ -5606,7 +5585,7 @@
               <a:buNone/>
             </a:pPr>
             <a:r>
-              <a:rPr lang="en-US" sz="1300" b="1" dirty="0">
+              <a:rPr lang="en-US" sz="1350" b="1" dirty="0">
                 <a:solidFill>
                   <a:srgbClr val="17222C"/>
                 </a:solidFill>
@@ -5614,9 +5593,9 @@
                 <a:ea typeface="Arial" pitchFamily="34" charset="-122"/>
                 <a:cs typeface="Arial" pitchFamily="34" charset="-120"/>
               </a:rPr>
-              <a:t>L'entrée de service</a:t>
-            </a:r>
-            <a:endParaRPr lang="en-US" sz="1300" dirty="0"/>
+              <a:t>Bastion</a:t>
+            </a:r>
+            <a:endParaRPr lang="en-US" sz="1350" dirty="0"/>
           </a:p>
         </p:txBody>
       </p:sp>
@@ -5653,7 +5632,7 @@
                 <a:ea typeface="Calibri" pitchFamily="34" charset="-122"/>
                 <a:cs typeface="Calibri" pitchFamily="34" charset="-120"/>
               </a:rPr>
-              <a:t>réservée à l'équipe, jamais aux clients</a:t>
+              <a:t>accès SSH pour Ansible uniquement</a:t>
             </a:r>
             <a:endParaRPr lang="en-US" sz="1100" dirty="0"/>
           </a:p>
@@ -5667,7 +5646,7 @@
         </p:nvSpPr>
         <p:spPr>
           <a:xfrm>
-            <a:off x="3611880" y="2871216"/>
+            <a:off x="3794760" y="2871216"/>
             <a:ext cx="0" cy="457200"/>
           </a:xfrm>
           <a:prstGeom prst="line">
@@ -5685,7 +5664,46 @@
       </p:sp>
       <p:sp>
         <p:nvSpPr>
-          <p:cNvPr id="22" name="Shape 20"/>
+          <p:cNvPr id="22" name="Text 20"/>
+          <p:cNvSpPr txBox="1"/>
+          <p:nvPr/>
+        </p:nvSpPr>
+        <p:spPr>
+          <a:xfrm>
+            <a:off x="3931920" y="2944368"/>
+            <a:ext cx="1005840" cy="228600"/>
+          </a:xfrm>
+          <a:prstGeom prst="rect">
+            <a:avLst/>
+          </a:prstGeom>
+          <a:noFill/>
+          <a:ln/>
+        </p:spPr>
+        <p:txBody>
+          <a:bodyPr wrap="square" lIns="0" tIns="0" rIns="0" bIns="0" rtlCol="0" anchor="ctr"/>
+          <a:lstStyle/>
+          <a:p>
+            <a:pPr indent="0" marL="0">
+              <a:buNone/>
+            </a:pPr>
+            <a:r>
+              <a:rPr lang="en-US" sz="900" dirty="0">
+                <a:solidFill>
+                  <a:srgbClr val="9E5D06"/>
+                </a:solidFill>
+                <a:latin typeface="Courier New" pitchFamily="34" charset="0"/>
+                <a:ea typeface="Courier New" pitchFamily="34" charset="-122"/>
+                <a:cs typeface="Courier New" pitchFamily="34" charset="-120"/>
+              </a:rPr>
+              <a:t>port 80</a:t>
+            </a:r>
+            <a:endParaRPr lang="en-US" sz="900" dirty="0"/>
+          </a:p>
+        </p:txBody>
+      </p:sp>
+      <p:sp>
+        <p:nvSpPr>
+          <p:cNvPr id="23" name="Shape 21"/>
           <p:cNvSpPr/>
           <p:nvPr/>
         </p:nvSpPr>
@@ -5709,14 +5727,53 @@
       </p:sp>
       <p:sp>
         <p:nvSpPr>
-          <p:cNvPr id="23" name="Shape 21"/>
+          <p:cNvPr id="24" name="Text 22"/>
+          <p:cNvSpPr txBox="1"/>
+          <p:nvPr/>
+        </p:nvSpPr>
+        <p:spPr>
+          <a:xfrm>
+            <a:off x="9966960" y="2944368"/>
+            <a:ext cx="1005840" cy="228600"/>
+          </a:xfrm>
+          <a:prstGeom prst="rect">
+            <a:avLst/>
+          </a:prstGeom>
+          <a:noFill/>
+          <a:ln/>
+        </p:spPr>
+        <p:txBody>
+          <a:bodyPr wrap="square" lIns="0" tIns="0" rIns="0" bIns="0" rtlCol="0" anchor="ctr"/>
+          <a:lstStyle/>
+          <a:p>
+            <a:pPr indent="0" marL="0">
+              <a:buNone/>
+            </a:pPr>
+            <a:r>
+              <a:rPr lang="en-US" sz="900" dirty="0">
+                <a:solidFill>
+                  <a:srgbClr val="5C6B7A"/>
+                </a:solidFill>
+                <a:latin typeface="Courier New" pitchFamily="34" charset="0"/>
+                <a:ea typeface="Courier New" pitchFamily="34" charset="-122"/>
+                <a:cs typeface="Courier New" pitchFamily="34" charset="-120"/>
+              </a:rPr>
+              <a:t>port 22</a:t>
+            </a:r>
+            <a:endParaRPr lang="en-US" sz="900" dirty="0"/>
+          </a:p>
+        </p:txBody>
+      </p:sp>
+      <p:sp>
+        <p:nvSpPr>
+          <p:cNvPr id="25" name="Shape 23"/>
           <p:cNvSpPr/>
           <p:nvPr/>
         </p:nvSpPr>
         <p:spPr>
           <a:xfrm>
-            <a:off x="1673352" y="3511296"/>
-            <a:ext cx="9601200" cy="749808"/>
+            <a:off x="1856232" y="3511296"/>
+            <a:ext cx="9418320" cy="749808"/>
           </a:xfrm>
           <a:prstGeom prst="roundRect">
             <a:avLst>
@@ -5736,30 +5793,30 @@
       </p:sp>
       <p:sp>
         <p:nvSpPr>
-          <p:cNvPr id="24" name="Text 22"/>
-          <p:cNvSpPr txBox="1"/>
-          <p:nvPr/>
-        </p:nvSpPr>
-        <p:spPr>
-          <a:xfrm>
-            <a:off x="1828800" y="3584448"/>
-            <a:ext cx="9235440" cy="274320"/>
-          </a:xfrm>
-          <a:prstGeom prst="rect">
-            <a:avLst/>
-          </a:prstGeom>
-          <a:noFill/>
-          <a:ln/>
-        </p:spPr>
-        <p:txBody>
-          <a:bodyPr wrap="square" lIns="0" tIns="0" rIns="0" bIns="0" rtlCol="0" anchor="ctr"/>
-          <a:lstStyle/>
-          <a:p>
-            <a:pPr indent="0" marL="0">
-              <a:buNone/>
-            </a:pPr>
-            <a:r>
-              <a:rPr lang="en-US" sz="1300" b="1" dirty="0">
+          <p:cNvPr id="26" name="Text 24"/>
+          <p:cNvSpPr txBox="1"/>
+          <p:nvPr/>
+        </p:nvSpPr>
+        <p:spPr>
+          <a:xfrm>
+            <a:off x="2011680" y="3584448"/>
+            <a:ext cx="9052560" cy="274320"/>
+          </a:xfrm>
+          <a:prstGeom prst="rect">
+            <a:avLst/>
+          </a:prstGeom>
+          <a:noFill/>
+          <a:ln/>
+        </p:spPr>
+        <p:txBody>
+          <a:bodyPr wrap="square" lIns="0" tIns="0" rIns="0" bIns="0" rtlCol="0" anchor="ctr"/>
+          <a:lstStyle/>
+          <a:p>
+            <a:pPr indent="0" marL="0">
+              <a:buNone/>
+            </a:pPr>
+            <a:r>
+              <a:rPr lang="en-US" sz="1350" b="1" dirty="0">
                 <a:solidFill>
                   <a:srgbClr val="17222C"/>
                 </a:solidFill>
@@ -5767,22 +5824,22 @@
                 <a:ea typeface="Arial" pitchFamily="34" charset="-122"/>
                 <a:cs typeface="Arial" pitchFamily="34" charset="-120"/>
               </a:rPr>
-              <a:t>Les caisses : des serveurs qui font tourner PrestaShop</a:t>
-            </a:r>
-            <a:endParaRPr lang="en-US" sz="1300" dirty="0"/>
-          </a:p>
-        </p:txBody>
-      </p:sp>
-      <p:sp>
-        <p:nvSpPr>
-          <p:cNvPr id="25" name="Text 23"/>
-          <p:cNvSpPr txBox="1"/>
-          <p:nvPr/>
-        </p:nvSpPr>
-        <p:spPr>
-          <a:xfrm>
-            <a:off x="1828800" y="3877056"/>
-            <a:ext cx="9235440" cy="274320"/>
+              <a:t>Serveurs EC2  —  conteneur Docker PrestaShop</a:t>
+            </a:r>
+            <a:endParaRPr lang="en-US" sz="1350" dirty="0"/>
+          </a:p>
+        </p:txBody>
+      </p:sp>
+      <p:sp>
+        <p:nvSpPr>
+          <p:cNvPr id="27" name="Text 25"/>
+          <p:cNvSpPr txBox="1"/>
+          <p:nvPr/>
+        </p:nvSpPr>
+        <p:spPr>
+          <a:xfrm>
+            <a:off x="2011680" y="3877056"/>
+            <a:ext cx="9052560" cy="274320"/>
           </a:xfrm>
           <a:prstGeom prst="rect">
             <a:avLst/>
@@ -5806,7 +5863,7 @@
                 <a:ea typeface="Calibri" pitchFamily="34" charset="-122"/>
                 <a:cs typeface="Calibri" pitchFamily="34" charset="-120"/>
               </a:rPr>
-              <a:t>toutes identiques, interchangeables — et aucune n'est joignable depuis Internet</a:t>
+              <a:t>identiques · répartis sur les zones · aucune adresse IP publique</a:t>
             </a:r>
             <a:endParaRPr lang="en-US" sz="1100" dirty="0"/>
           </a:p>
@@ -5814,13 +5871,13 @@
       </p:sp>
       <p:sp>
         <p:nvSpPr>
-          <p:cNvPr id="26" name="Shape 24"/>
+          <p:cNvPr id="28" name="Shape 26"/>
           <p:cNvSpPr/>
           <p:nvPr/>
         </p:nvSpPr>
         <p:spPr>
           <a:xfrm>
-            <a:off x="3611880" y="4279392"/>
+            <a:off x="3794760" y="4279392"/>
             <a:ext cx="0" cy="420624"/>
           </a:xfrm>
           <a:prstGeom prst="line">
@@ -5838,7 +5895,46 @@
       </p:sp>
       <p:sp>
         <p:nvSpPr>
-          <p:cNvPr id="27" name="Shape 25"/>
+          <p:cNvPr id="29" name="Text 27"/>
+          <p:cNvSpPr txBox="1"/>
+          <p:nvPr/>
+        </p:nvSpPr>
+        <p:spPr>
+          <a:xfrm>
+            <a:off x="3931920" y="4334256"/>
+            <a:ext cx="1188720" cy="228600"/>
+          </a:xfrm>
+          <a:prstGeom prst="rect">
+            <a:avLst/>
+          </a:prstGeom>
+          <a:noFill/>
+          <a:ln/>
+        </p:spPr>
+        <p:txBody>
+          <a:bodyPr wrap="square" lIns="0" tIns="0" rIns="0" bIns="0" rtlCol="0" anchor="ctr"/>
+          <a:lstStyle/>
+          <a:p>
+            <a:pPr indent="0" marL="0">
+              <a:buNone/>
+            </a:pPr>
+            <a:r>
+              <a:rPr lang="en-US" sz="900" dirty="0">
+                <a:solidFill>
+                  <a:srgbClr val="0C6A72"/>
+                </a:solidFill>
+                <a:latin typeface="Courier New" pitchFamily="34" charset="0"/>
+                <a:ea typeface="Courier New" pitchFamily="34" charset="-122"/>
+                <a:cs typeface="Courier New" pitchFamily="34" charset="-120"/>
+              </a:rPr>
+              <a:t>port 3306</a:t>
+            </a:r>
+            <a:endParaRPr lang="en-US" sz="900" dirty="0"/>
+          </a:p>
+        </p:txBody>
+      </p:sp>
+      <p:sp>
+        <p:nvSpPr>
+          <p:cNvPr id="30" name="Shape 28"/>
           <p:cNvSpPr/>
           <p:nvPr/>
         </p:nvSpPr>
@@ -5862,14 +5958,53 @@
       </p:sp>
       <p:sp>
         <p:nvSpPr>
-          <p:cNvPr id="28" name="Shape 26"/>
+          <p:cNvPr id="31" name="Text 29"/>
+          <p:cNvSpPr txBox="1"/>
+          <p:nvPr/>
+        </p:nvSpPr>
+        <p:spPr>
+          <a:xfrm>
+            <a:off x="9052560" y="4334256"/>
+            <a:ext cx="1188720" cy="228600"/>
+          </a:xfrm>
+          <a:prstGeom prst="rect">
+            <a:avLst/>
+          </a:prstGeom>
+          <a:noFill/>
+          <a:ln/>
+        </p:spPr>
+        <p:txBody>
+          <a:bodyPr wrap="square" lIns="0" tIns="0" rIns="0" bIns="0" rtlCol="0" anchor="ctr"/>
+          <a:lstStyle/>
+          <a:p>
+            <a:pPr indent="0" marL="0">
+              <a:buNone/>
+            </a:pPr>
+            <a:r>
+              <a:rPr lang="en-US" sz="900" dirty="0">
+                <a:solidFill>
+                  <a:srgbClr val="0C6A72"/>
+                </a:solidFill>
+                <a:latin typeface="Courier New" pitchFamily="34" charset="0"/>
+                <a:ea typeface="Courier New" pitchFamily="34" charset="-122"/>
+                <a:cs typeface="Courier New" pitchFamily="34" charset="-120"/>
+              </a:rPr>
+              <a:t>port 2049</a:t>
+            </a:r>
+            <a:endParaRPr lang="en-US" sz="900" dirty="0"/>
+          </a:p>
+        </p:txBody>
+      </p:sp>
+      <p:sp>
+        <p:nvSpPr>
+          <p:cNvPr id="32" name="Shape 30"/>
           <p:cNvSpPr/>
           <p:nvPr/>
         </p:nvSpPr>
         <p:spPr>
           <a:xfrm>
-            <a:off x="1673352" y="4882896"/>
-            <a:ext cx="4663440" cy="877824"/>
+            <a:off x="1856232" y="4882896"/>
+            <a:ext cx="4572000" cy="877824"/>
           </a:xfrm>
           <a:prstGeom prst="roundRect">
             <a:avLst>
@@ -5889,30 +6024,30 @@
       </p:sp>
       <p:sp>
         <p:nvSpPr>
-          <p:cNvPr id="29" name="Text 27"/>
-          <p:cNvSpPr txBox="1"/>
-          <p:nvPr/>
-        </p:nvSpPr>
-        <p:spPr>
-          <a:xfrm>
-            <a:off x="1828800" y="4974336"/>
-            <a:ext cx="4389120" cy="274320"/>
-          </a:xfrm>
-          <a:prstGeom prst="rect">
-            <a:avLst/>
-          </a:prstGeom>
-          <a:noFill/>
-          <a:ln/>
-        </p:spPr>
-        <p:txBody>
-          <a:bodyPr wrap="square" lIns="0" tIns="0" rIns="0" bIns="0" rtlCol="0" anchor="ctr"/>
-          <a:lstStyle/>
-          <a:p>
-            <a:pPr indent="0" marL="0">
-              <a:buNone/>
-            </a:pPr>
-            <a:r>
-              <a:rPr lang="en-US" sz="1300" b="1" dirty="0">
+          <p:cNvPr id="33" name="Text 31"/>
+          <p:cNvSpPr txBox="1"/>
+          <p:nvPr/>
+        </p:nvSpPr>
+        <p:spPr>
+          <a:xfrm>
+            <a:off x="2011680" y="4974336"/>
+            <a:ext cx="4297680" cy="274320"/>
+          </a:xfrm>
+          <a:prstGeom prst="rect">
+            <a:avLst/>
+          </a:prstGeom>
+          <a:noFill/>
+          <a:ln/>
+        </p:spPr>
+        <p:txBody>
+          <a:bodyPr wrap="square" lIns="0" tIns="0" rIns="0" bIns="0" rtlCol="0" anchor="ctr"/>
+          <a:lstStyle/>
+          <a:p>
+            <a:pPr indent="0" marL="0">
+              <a:buNone/>
+            </a:pPr>
+            <a:r>
+              <a:rPr lang="en-US" sz="1350" b="1" dirty="0">
                 <a:solidFill>
                   <a:srgbClr val="17222C"/>
                 </a:solidFill>
@@ -5920,22 +6055,22 @@
                 <a:ea typeface="Arial" pitchFamily="34" charset="-122"/>
                 <a:cs typeface="Arial" pitchFamily="34" charset="-120"/>
               </a:rPr>
-              <a:t>Le coffre : la base de données</a:t>
-            </a:r>
-            <a:endParaRPr lang="en-US" sz="1300" dirty="0"/>
-          </a:p>
-        </p:txBody>
-      </p:sp>
-      <p:sp>
-        <p:nvSpPr>
-          <p:cNvPr id="30" name="Text 28"/>
-          <p:cNvSpPr txBox="1"/>
-          <p:nvPr/>
-        </p:nvSpPr>
-        <p:spPr>
-          <a:xfrm>
-            <a:off x="1828800" y="5285232"/>
-            <a:ext cx="4389120" cy="320040"/>
+              <a:t>Base de données RDS MySQL</a:t>
+            </a:r>
+            <a:endParaRPr lang="en-US" sz="1350" dirty="0"/>
+          </a:p>
+        </p:txBody>
+      </p:sp>
+      <p:sp>
+        <p:nvSpPr>
+          <p:cNvPr id="34" name="Text 32"/>
+          <p:cNvSpPr txBox="1"/>
+          <p:nvPr/>
+        </p:nvSpPr>
+        <p:spPr>
+          <a:xfrm>
+            <a:off x="2011680" y="5285232"/>
+            <a:ext cx="4297680" cy="320040"/>
           </a:xfrm>
           <a:prstGeom prst="rect">
             <a:avLst/>
@@ -5959,7 +6094,7 @@
                 <a:ea typeface="Calibri" pitchFamily="34" charset="-122"/>
                 <a:cs typeface="Calibri" pitchFamily="34" charset="-120"/>
               </a:rPr>
-              <a:t>les billets, les paniers, les commandes</a:t>
+              <a:t>catalogue, paniers, commandes</a:t>
             </a:r>
             <a:endParaRPr lang="en-US" sz="1100" dirty="0"/>
           </a:p>
@@ -5967,14 +6102,14 @@
       </p:sp>
       <p:sp>
         <p:nvSpPr>
-          <p:cNvPr id="31" name="Shape 29"/>
+          <p:cNvPr id="35" name="Shape 33"/>
           <p:cNvSpPr/>
           <p:nvPr/>
         </p:nvSpPr>
         <p:spPr>
           <a:xfrm>
-            <a:off x="6629400" y="4882896"/>
-            <a:ext cx="4663440" cy="877824"/>
+            <a:off x="6720840" y="4882896"/>
+            <a:ext cx="4572000" cy="877824"/>
           </a:xfrm>
           <a:prstGeom prst="roundRect">
             <a:avLst>
@@ -5994,30 +6129,30 @@
       </p:sp>
       <p:sp>
         <p:nvSpPr>
-          <p:cNvPr id="32" name="Text 30"/>
-          <p:cNvSpPr txBox="1"/>
-          <p:nvPr/>
-        </p:nvSpPr>
-        <p:spPr>
-          <a:xfrm>
-            <a:off x="6793992" y="4974336"/>
-            <a:ext cx="4389120" cy="274320"/>
-          </a:xfrm>
-          <a:prstGeom prst="rect">
-            <a:avLst/>
-          </a:prstGeom>
-          <a:noFill/>
-          <a:ln/>
-        </p:spPr>
-        <p:txBody>
-          <a:bodyPr wrap="square" lIns="0" tIns="0" rIns="0" bIns="0" rtlCol="0" anchor="ctr"/>
-          <a:lstStyle/>
-          <a:p>
-            <a:pPr indent="0" marL="0">
-              <a:buNone/>
-            </a:pPr>
-            <a:r>
-              <a:rPr lang="en-US" sz="1300" b="1" dirty="0">
+          <p:cNvPr id="36" name="Text 34"/>
+          <p:cNvSpPr txBox="1"/>
+          <p:nvPr/>
+        </p:nvSpPr>
+        <p:spPr>
+          <a:xfrm>
+            <a:off x="6885432" y="4974336"/>
+            <a:ext cx="4297680" cy="274320"/>
+          </a:xfrm>
+          <a:prstGeom prst="rect">
+            <a:avLst/>
+          </a:prstGeom>
+          <a:noFill/>
+          <a:ln/>
+        </p:spPr>
+        <p:txBody>
+          <a:bodyPr wrap="square" lIns="0" tIns="0" rIns="0" bIns="0" rtlCol="0" anchor="ctr"/>
+          <a:lstStyle/>
+          <a:p>
+            <a:pPr indent="0" marL="0">
+              <a:buNone/>
+            </a:pPr>
+            <a:r>
+              <a:rPr lang="en-US" sz="1350" b="1" dirty="0">
                 <a:solidFill>
                   <a:srgbClr val="17222C"/>
                 </a:solidFill>
@@ -6025,22 +6160,22 @@
                 <a:ea typeface="Arial" pitchFamily="34" charset="-122"/>
                 <a:cs typeface="Arial" pitchFamily="34" charset="-120"/>
               </a:rPr>
-              <a:t>Le vestiaire : un disque partagé</a:t>
-            </a:r>
-            <a:endParaRPr lang="en-US" sz="1300" dirty="0"/>
-          </a:p>
-        </p:txBody>
-      </p:sp>
-      <p:sp>
-        <p:nvSpPr>
-          <p:cNvPr id="33" name="Text 31"/>
-          <p:cNvSpPr txBox="1"/>
-          <p:nvPr/>
-        </p:nvSpPr>
-        <p:spPr>
-          <a:xfrm>
-            <a:off x="6793992" y="5285232"/>
-            <a:ext cx="4389120" cy="320040"/>
+              <a:t>Disque partagé EFS</a:t>
+            </a:r>
+            <a:endParaRPr lang="en-US" sz="1350" dirty="0"/>
+          </a:p>
+        </p:txBody>
+      </p:sp>
+      <p:sp>
+        <p:nvSpPr>
+          <p:cNvPr id="37" name="Text 35"/>
+          <p:cNvSpPr txBox="1"/>
+          <p:nvPr/>
+        </p:nvSpPr>
+        <p:spPr>
+          <a:xfrm>
+            <a:off x="6885432" y="5285232"/>
+            <a:ext cx="4297680" cy="320040"/>
           </a:xfrm>
           <a:prstGeom prst="rect">
             <a:avLst/>
@@ -6064,7 +6199,7 @@
                 <a:ea typeface="Calibri" pitchFamily="34" charset="-122"/>
                 <a:cs typeface="Calibri" pitchFamily="34" charset="-120"/>
               </a:rPr>
-              <a:t>les images, le thème, et les paniers en cours</a:t>
+              <a:t>images, thème, sessions PHP</a:t>
             </a:r>
             <a:endParaRPr lang="en-US" sz="1100" dirty="0"/>
           </a:p>
@@ -6072,7 +6207,7 @@
       </p:sp>
       <p:sp>
         <p:nvSpPr>
-          <p:cNvPr id="34" name="Text 32"/>
+          <p:cNvPr id="38" name="Text 36"/>
           <p:cNvSpPr txBox="1"/>
           <p:nvPr/>
         </p:nvSpPr>
@@ -6095,7 +6230,7 @@
               <a:buNone/>
             </a:pPr>
             <a:r>
-              <a:rPr lang="en-US" sz="1500" i="1" dirty="0">
+              <a:rPr lang="en-US" sz="1500" b="1" dirty="0">
                 <a:solidFill>
                   <a:srgbClr val="9E5D06"/>
                 </a:solidFill>
@@ -6103,7 +6238,7 @@
                 <a:ea typeface="Calibri" pitchFamily="34" charset="-122"/>
                 <a:cs typeface="Calibri" pitchFamily="34" charset="-120"/>
               </a:rPr>
-              <a:t>Les caisses ne gardent rien : tout est dans le coffre et le vestiaire. C'est ce qui rend tout le reste possible.</a:t>
+              <a:t>Les serveurs ne stockent aucune donnée : tout est dans la base ou sur le disque partagé.</a:t>
             </a:r>
             <a:endParaRPr lang="en-US" sz="1500" dirty="0"/>
           </a:p>
@@ -6245,7 +6380,7 @@
                 <a:ea typeface="Calibri" pitchFamily="34" charset="-122"/>
                 <a:cs typeface="Calibri" pitchFamily="34" charset="-120"/>
               </a:rPr>
-              <a:t>La règle qu'on s'est donnée : on garde la main sur ce qui est propre à la boutique, et on laisse à AWS ce que personne n'a envie de réparer un soir d'ouverture.</a:t>
+              <a:t>Le sujet nous laissait libres de répartir. Nous avons gardé ce qui est propre à la boutique, et confié à AWS ce qui est standard.</a:t>
             </a:r>
             <a:endParaRPr lang="en-US" sz="1400" dirty="0"/>
           </a:p>
@@ -6274,9 +6409,9 @@
             <a:tbl>
               <a:tblPr/>
               <a:tblGrid>
-                <a:gridCol w="2011680"/>
+                <a:gridCol w="2103120"/>
                 <a:gridCol w="2468880"/>
-                <a:gridCol w="6574536"/>
+                <a:gridCol w="6483096"/>
               </a:tblGrid>
               <a:tr h="566928">
                 <a:tc>
@@ -6296,7 +6431,7 @@
                           <a:ea typeface="Calibri" pitchFamily="34" charset="-122"/>
                           <a:cs typeface="Calibri" pitchFamily="34" charset="-120"/>
                         </a:rPr>
-                        <a:t>QUOI</a:t>
+                        <a:t>COMPOSANT</a:t>
                       </a:r>
                       <a:endParaRPr lang="en-US" sz="1250" dirty="0">
                         <a:latin typeface="Calibri" charset="0"/>
@@ -6364,7 +6499,7 @@
                           <a:ea typeface="Calibri" pitchFamily="34" charset="-122"/>
                           <a:cs typeface="Calibri" pitchFamily="34" charset="-120"/>
                         </a:rPr>
-                        <a:t>NOTRE CHOIX</a:t>
+                        <a:t>CHOIX</a:t>
                       </a:r>
                       <a:endParaRPr lang="en-US" sz="1250" dirty="0">
                         <a:latin typeface="Calibri" charset="0"/>
@@ -6432,7 +6567,7 @@
                           <a:ea typeface="Calibri" pitchFamily="34" charset="-122"/>
                           <a:cs typeface="Calibri" pitchFamily="34" charset="-120"/>
                         </a:rPr>
-                        <a:t>POURQUOI</a:t>
+                        <a:t>RAISON</a:t>
                       </a:r>
                       <a:endParaRPr lang="en-US" sz="1250" dirty="0">
                         <a:latin typeface="Calibri" charset="0"/>
@@ -6502,7 +6637,7 @@
                           <a:ea typeface="Calibri" pitchFamily="34" charset="-122"/>
                           <a:cs typeface="Calibri" pitchFamily="34" charset="-120"/>
                         </a:rPr>
-                        <a:t>La boutique</a:t>
+                        <a:t>Application</a:t>
                       </a:r>
                       <a:endParaRPr lang="en-US" sz="1250" dirty="0">
                         <a:latin typeface="Calibri" charset="0"/>
@@ -6570,7 +6705,7 @@
                           <a:ea typeface="Calibri" pitchFamily="34" charset="-122"/>
                           <a:cs typeface="Calibri" pitchFamily="34" charset="-120"/>
                         </a:rPr>
-                        <a:t>Docker sur un serveur EC2</a:t>
+                        <a:t>Docker sur EC2</a:t>
                       </a:r>
                       <a:endParaRPr lang="en-US" sz="1250" dirty="0">
                         <a:latin typeface="Calibri" charset="0"/>
@@ -6638,7 +6773,7 @@
                           <a:ea typeface="Calibri" pitchFamily="34" charset="-122"/>
                           <a:cs typeface="Calibri" pitchFamily="34" charset="-120"/>
                         </a:rPr>
-                        <a:t>Le sujet demande l'image PrestaShop sur EC2. Changer de version, c'est une ligne à modifier.</a:t>
+                        <a:t>Le sujet impose l'image PrestaShop sur une instance EC2 configurée par Ansible. Changer de version se fait en une ligne.</a:t>
                       </a:r>
                       <a:endParaRPr lang="en-US" sz="1250" dirty="0">
                         <a:latin typeface="Calibri" charset="0"/>
@@ -6708,7 +6843,7 @@
                           <a:ea typeface="Calibri" pitchFamily="34" charset="-122"/>
                           <a:cs typeface="Calibri" pitchFamily="34" charset="-120"/>
                         </a:rPr>
-                        <a:t>La base de données</a:t>
+                        <a:t>Base de données</a:t>
                       </a:r>
                       <a:endParaRPr lang="en-US" sz="1250" dirty="0">
                         <a:latin typeface="Calibri" charset="0"/>
@@ -6776,7 +6911,7 @@
                           <a:ea typeface="Calibri" pitchFamily="34" charset="-122"/>
                           <a:cs typeface="Calibri" pitchFamily="34" charset="-120"/>
                         </a:rPr>
-                        <a:t>RDS, le service géré d'AWS</a:t>
+                        <a:t>RDS MySQL (managé)</a:t>
                       </a:r>
                       <a:endParaRPr lang="en-US" sz="1250" dirty="0">
                         <a:latin typeface="Calibri" charset="0"/>
@@ -6844,7 +6979,7 @@
                           <a:ea typeface="Calibri" pitchFamily="34" charset="-122"/>
                           <a:cs typeface="Calibri" pitchFamily="34" charset="-120"/>
                         </a:rPr>
-                        <a:t>Sauvegardes, mises à jour, machine de secours : AWS le fait mieux que nous, et sans nous réveiller la nuit.</a:t>
+                        <a:t>AWS gère les sauvegardes, les mises à jour et le basculement automatique vers une instance de secours.</a:t>
                       </a:r>
                       <a:endParaRPr lang="en-US" sz="1250" dirty="0">
                         <a:latin typeface="Calibri" charset="0"/>
@@ -6914,7 +7049,7 @@
                           <a:ea typeface="Calibri" pitchFamily="34" charset="-122"/>
                           <a:cs typeface="Calibri" pitchFamily="34" charset="-120"/>
                         </a:rPr>
-                        <a:t>Les fichiers</a:t>
+                        <a:t>Fichiers</a:t>
                       </a:r>
                       <a:endParaRPr lang="en-US" sz="1250" dirty="0">
                         <a:latin typeface="Calibri" charset="0"/>
@@ -6982,7 +7117,7 @@
                           <a:ea typeface="Calibri" pitchFamily="34" charset="-122"/>
                           <a:cs typeface="Calibri" pitchFamily="34" charset="-120"/>
                         </a:rPr>
-                        <a:t>EFS, un disque partagé</a:t>
+                        <a:t>EFS (disque partagé)</a:t>
                       </a:r>
                       <a:endParaRPr lang="en-US" sz="1250" dirty="0">
                         <a:latin typeface="Calibri" charset="0"/>
@@ -7050,7 +7185,7 @@
                           <a:ea typeface="Calibri" pitchFamily="34" charset="-122"/>
                           <a:cs typeface="Calibri" pitchFamily="34" charset="-120"/>
                         </a:rPr>
-                        <a:t>Plusieurs serveurs doivent voir les mêmes images. Un disque normal ne se partage pas.</a:t>
+                        <a:t>Plusieurs serveurs doivent lire et écrire les mêmes fichiers. Un disque EBS ne se partage pas.</a:t>
                       </a:r>
                       <a:endParaRPr lang="en-US" sz="1250" dirty="0">
                         <a:latin typeface="Calibri" charset="0"/>
@@ -7120,7 +7255,7 @@
                           <a:ea typeface="Calibri" pitchFamily="34" charset="-122"/>
                           <a:cs typeface="Calibri" pitchFamily="34" charset="-120"/>
                         </a:rPr>
-                        <a:t>L'entrée</a:t>
+                        <a:t>Point d'entrée</a:t>
                       </a:r>
                       <a:endParaRPr lang="en-US" sz="1250" dirty="0">
                         <a:latin typeface="Calibri" charset="0"/>
@@ -7188,7 +7323,7 @@
                           <a:ea typeface="Calibri" pitchFamily="34" charset="-122"/>
                           <a:cs typeface="Calibri" pitchFamily="34" charset="-120"/>
                         </a:rPr>
-                        <a:t>Un load balancer</a:t>
+                        <a:t>Load balancer (ALB)</a:t>
                       </a:r>
                       <a:endParaRPr lang="en-US" sz="1250" dirty="0">
                         <a:latin typeface="Calibri" charset="0"/>
@@ -7256,7 +7391,7 @@
                           <a:ea typeface="Calibri" pitchFamily="34" charset="-122"/>
                           <a:cs typeface="Calibri" pitchFamily="34" charset="-120"/>
                         </a:rPr>
-                        <a:t>Il surveille les serveurs et répartit les visiteurs tout seul.</a:t>
+                        <a:t>Il surveille l'état des serveurs et répartit les requêtes entre les zones.</a:t>
                       </a:r>
                       <a:endParaRPr lang="en-US" sz="1250" dirty="0">
                         <a:latin typeface="Calibri" charset="0"/>
@@ -7326,7 +7461,7 @@
                           <a:ea typeface="Calibri" pitchFamily="34" charset="-122"/>
                           <a:cs typeface="Calibri" pitchFamily="34" charset="-120"/>
                         </a:rPr>
-                        <a:t>Les mots de passe</a:t>
+                        <a:t>Secrets</a:t>
                       </a:r>
                       <a:endParaRPr lang="en-US" sz="1250" dirty="0">
                         <a:latin typeface="Calibri" charset="0"/>
@@ -7394,7 +7529,7 @@
                           <a:ea typeface="Calibri" pitchFamily="34" charset="-122"/>
                           <a:cs typeface="Calibri" pitchFamily="34" charset="-120"/>
                         </a:rPr>
-                        <a:t>Coffre AWS + Ansible Vault</a:t>
+                        <a:t>Secrets Manager + Vault</a:t>
                       </a:r>
                       <a:endParaRPr lang="en-US" sz="1250" dirty="0">
                         <a:latin typeface="Calibri" charset="0"/>
@@ -7462,7 +7597,7 @@
                           <a:ea typeface="Calibri" pitchFamily="34" charset="-122"/>
                           <a:cs typeface="Calibri" pitchFamily="34" charset="-120"/>
                         </a:rPr>
-                        <a:t>Le mot de passe de la base n'est écrit nulle part : chaque serveur va le chercher lui-même.</a:t>
+                        <a:t>Le mot de passe de la base n'est pas dans le dépôt. Chaque serveur le lit avec son rôle IAM.</a:t>
                       </a:r>
                       <a:endParaRPr lang="en-US" sz="1250" dirty="0">
                         <a:latin typeface="Calibri" charset="0"/>
@@ -7532,7 +7667,7 @@
                           <a:ea typeface="Calibri" pitchFamily="34" charset="-122"/>
                           <a:cs typeface="Calibri" pitchFamily="34" charset="-120"/>
                         </a:rPr>
-                        <a:t>Notre accès</a:t>
+                        <a:t>Accès administration</a:t>
                       </a:r>
                       <a:endParaRPr lang="en-US" sz="1250" dirty="0">
                         <a:latin typeface="Calibri" charset="0"/>
@@ -7600,7 +7735,7 @@
                           <a:ea typeface="Calibri" pitchFamily="34" charset="-122"/>
                           <a:cs typeface="Calibri" pitchFamily="34" charset="-120"/>
                         </a:rPr>
-                        <a:t>Un serveur d'entrée dédié</a:t>
+                        <a:t>Bastion SSH</a:t>
                       </a:r>
                       <a:endParaRPr lang="en-US" sz="1250" dirty="0">
                         <a:latin typeface="Calibri" charset="0"/>
@@ -7668,7 +7803,7 @@
                           <a:ea typeface="Calibri" pitchFamily="34" charset="-122"/>
                           <a:cs typeface="Calibri" pitchFamily="34" charset="-120"/>
                         </a:rPr>
-                        <a:t>Une seule porte pour l'équipe, ouverte à une seule adresse IP.</a:t>
+                        <a:t>Les serveurs n'ont pas d'adresse publique. Un seul point d'accès, limité à notre IP.</a:t>
                       </a:r>
                       <a:endParaRPr lang="en-US" sz="1250" dirty="0">
                         <a:latin typeface="Calibri" charset="0"/>
@@ -7821,7 +7956,7 @@
                 <a:ea typeface="Arial" pitchFamily="34" charset="-122"/>
                 <a:cs typeface="Arial" pitchFamily="34" charset="-120"/>
               </a:rPr>
-              <a:t>On décrit ce qu'on veut, Terraform le construit</a:t>
+              <a:t>Terraform crée l'infrastructure</a:t>
             </a:r>
             <a:endParaRPr lang="en-US" sz="3000" dirty="0"/>
           </a:p>
@@ -7860,7 +7995,7 @@
                 <a:ea typeface="Calibri" pitchFamily="34" charset="-122"/>
                 <a:cs typeface="Calibri" pitchFamily="34" charset="-120"/>
               </a:rPr>
-              <a:t>Six briques, une par couche. On les assemble, et la même description donne un petit environnement de test ou une vraie production.</a:t>
+              <a:t>Le code est découpé en six modules, un par couche. Chaque module a ses variables et ses sorties, et peut être relu séparément.</a:t>
             </a:r>
             <a:endParaRPr lang="en-US" sz="1400" dirty="0"/>
           </a:p>
@@ -7963,7 +8098,7 @@
                 <a:ea typeface="Calibri" pitchFamily="34" charset="-122"/>
                 <a:cs typeface="Calibri" pitchFamily="34" charset="-120"/>
               </a:rPr>
-              <a:t>le réseau et ses trois niveaux</a:t>
+              <a:t>VPC, sous-réseaux, NAT, routes</a:t>
             </a:r>
             <a:endParaRPr lang="en-US" sz="1250" dirty="0"/>
           </a:p>
@@ -8066,7 +8201,7 @@
                 <a:ea typeface="Calibri" pitchFamily="34" charset="-122"/>
                 <a:cs typeface="Calibri" pitchFamily="34" charset="-120"/>
               </a:rPr>
-              <a:t>qui a le droit de parler à qui</a:t>
+              <a:t>groupes de sécurité</a:t>
             </a:r>
             <a:endParaRPr lang="en-US" sz="1250" dirty="0"/>
           </a:p>
@@ -8169,7 +8304,7 @@
                 <a:ea typeface="Calibri" pitchFamily="34" charset="-122"/>
                 <a:cs typeface="Calibri" pitchFamily="34" charset="-120"/>
               </a:rPr>
-              <a:t>le disque partagé</a:t>
+              <a:t>disque partagé EFS</a:t>
             </a:r>
             <a:endParaRPr lang="en-US" sz="1250" dirty="0"/>
           </a:p>
@@ -8272,7 +8407,7 @@
                 <a:ea typeface="Calibri" pitchFamily="34" charset="-122"/>
                 <a:cs typeface="Calibri" pitchFamily="34" charset="-120"/>
               </a:rPr>
-              <a:t>la base de données</a:t>
+              <a:t>RDS MySQL, Secrets Manager</a:t>
             </a:r>
             <a:endParaRPr lang="en-US" sz="1250" dirty="0"/>
           </a:p>
@@ -8375,7 +8510,7 @@
                 <a:ea typeface="Calibri" pitchFamily="34" charset="-122"/>
                 <a:cs typeface="Calibri" pitchFamily="34" charset="-120"/>
               </a:rPr>
-              <a:t>les serveurs</a:t>
+              <a:t>instances EC2, bastion, rôle IAM</a:t>
             </a:r>
             <a:endParaRPr lang="en-US" sz="1250" dirty="0"/>
           </a:p>
@@ -8478,7 +8613,7 @@
                 <a:ea typeface="Calibri" pitchFamily="34" charset="-122"/>
                 <a:cs typeface="Calibri" pitchFamily="34" charset="-120"/>
               </a:rPr>
-              <a:t>l'entrée et la surveillance</a:t>
+              <a:t>ALB, alarmes CloudWatch</a:t>
             </a:r>
             <a:endParaRPr lang="en-US" sz="1250" dirty="0"/>
           </a:p>
@@ -8583,7 +8718,7 @@
                 <a:ea typeface="Calibri" pitchFamily="34" charset="-122"/>
                 <a:cs typeface="Calibri" pitchFamily="34" charset="-120"/>
               </a:rPr>
-              <a:t>Test, pré-production, production : on change un mot, pas le code. Le test a 1 serveur, la production en a 3 répartis sur 3 zones.</a:t>
+              <a:t>dev, staging et prod utilisent le même code. Une table de variables définit les tailles : 1 serveur en dev, 3 serveurs sur 3 zones en prod.</a:t>
             </a:r>
             <a:endParaRPr lang="en-US" sz="1150" dirty="0"/>
           </a:p>
@@ -8649,7 +8784,7 @@
                 <a:ea typeface="Arial" pitchFamily="34" charset="-122"/>
                 <a:cs typeface="Arial" pitchFamily="34" charset="-120"/>
               </a:rPr>
-              <a:t>Le travail à trois est protégé</a:t>
+              <a:t>État distant et verrouillage</a:t>
             </a:r>
             <a:endParaRPr lang="en-US" sz="1300" dirty="0"/>
           </a:p>
@@ -8688,7 +8823,7 @@
                 <a:ea typeface="Calibri" pitchFamily="34" charset="-122"/>
                 <a:cs typeface="Calibri" pitchFamily="34" charset="-120"/>
               </a:rPr>
-              <a:t>La description de l'infrastructure est stockée sur AWS, verrouillée : deux personnes ne peuvent pas la modifier en même temps.</a:t>
+              <a:t>L'état Terraform est dans un bucket S3 versionné et chiffré, avec un verrou. Deux personnes ne peuvent pas modifier en même temps.</a:t>
             </a:r>
             <a:endParaRPr lang="en-US" sz="1150" dirty="0"/>
           </a:p>
@@ -8754,7 +8889,7 @@
                 <a:ea typeface="Arial" pitchFamily="34" charset="-122"/>
                 <a:cs typeface="Arial" pitchFamily="34" charset="-120"/>
               </a:rPr>
-              <a:t>Rien n'est écrit en dur</a:t>
+              <a:t>Valeurs résolues automatiquement</a:t>
             </a:r>
             <a:endParaRPr lang="en-US" sz="1300" dirty="0"/>
           </a:p>
@@ -8793,7 +8928,7 @@
                 <a:ea typeface="Calibri" pitchFamily="34" charset="-122"/>
                 <a:cs typeface="Calibri" pitchFamily="34" charset="-120"/>
               </a:rPr>
-              <a:t>Terraform va chercher lui-même l'image système, les zones disponibles, et même notre adresse IP — celle qui aura le droit de se connecter.</a:t>
+              <a:t>L'AMI Ubuntu, la liste des zones et notre adresse IP publique sont lues à l'exécution, pas écrites en dur dans le code.</a:t>
             </a:r>
             <a:endParaRPr lang="en-US" sz="1150" dirty="0"/>
           </a:p>
@@ -8896,7 +9031,7 @@
                 <a:ea typeface="Arial" pitchFamily="34" charset="-122"/>
                 <a:cs typeface="Arial" pitchFamily="34" charset="-120"/>
               </a:rPr>
-              <a:t>Ansible lit les adresses chez Terraform</a:t>
+              <a:t>Ansible configure les serveurs</a:t>
             </a:r>
             <a:endParaRPr lang="en-US" sz="3000" dirty="0"/>
           </a:p>
@@ -8935,7 +9070,7 @@
                 <a:ea typeface="Calibri" pitchFamily="34" charset="-122"/>
                 <a:cs typeface="Calibri" pitchFamily="34" charset="-120"/>
               </a:rPr>
-              <a:t>Terraform connaît déjà les adresses des serveurs. Plutôt que de les recopier à la main, Ansible va les lire chez lui.</a:t>
+              <a:t>Terraform connaît les adresses des serveurs. Ansible les lit directement dans l'état Terraform, au lieu qu'on les recopie.</a:t>
             </a:r>
             <a:endParaRPr lang="en-US" sz="1400" dirty="0"/>
           </a:p>
@@ -8949,7 +9084,7 @@
         </p:nvSpPr>
         <p:spPr>
           <a:xfrm>
-            <a:off x="566928" y="1938528"/>
+            <a:off x="566928" y="1920240"/>
             <a:ext cx="6537960" cy="2286000"/>
           </a:xfrm>
           <a:prstGeom prst="roundRect">
@@ -8976,7 +9111,7 @@
         </p:nvSpPr>
         <p:spPr>
           <a:xfrm>
-            <a:off x="731520" y="2048256"/>
+            <a:off x="731520" y="2029968"/>
             <a:ext cx="6208776" cy="2066544"/>
           </a:xfrm>
           <a:prstGeom prst="rect">
@@ -9004,7 +9139,7 @@
                 <a:ea typeface="Courier New" pitchFamily="34" charset="-122"/>
                 <a:cs typeface="Courier New" pitchFamily="34" charset="-120"/>
               </a:rPr>
-              <a:t># Terraform écrit la liste des serveurs…</a:t>
+              <a:t># Terraform déclare les serveurs et leurs informations</a:t>
             </a:r>
             <a:endParaRPr lang="en-US" sz="1150" dirty="0"/>
           </a:p>
@@ -9133,7 +9268,7 @@
                 <a:ea typeface="Courier New" pitchFamily="34" charset="-122"/>
                 <a:cs typeface="Courier New" pitchFamily="34" charset="-120"/>
               </a:rPr>
-              <a:t># …et Ansible la relit. C'est tout.</a:t>
+              <a:t># Ansible les lit depuis l'état Terraform</a:t>
             </a:r>
             <a:endParaRPr lang="en-US" sz="1150" dirty="0"/>
           </a:p>
@@ -9167,7 +9302,7 @@
         </p:nvSpPr>
         <p:spPr>
           <a:xfrm>
-            <a:off x="7360920" y="1938528"/>
+            <a:off x="7360920" y="1920240"/>
             <a:ext cx="4261104" cy="1234440"/>
           </a:xfrm>
           <a:prstGeom prst="roundRect">
@@ -9194,7 +9329,7 @@
         </p:nvSpPr>
         <p:spPr>
           <a:xfrm>
-            <a:off x="7543800" y="2057400"/>
+            <a:off x="7543800" y="2039112"/>
             <a:ext cx="3931920" cy="274320"/>
           </a:xfrm>
           <a:prstGeom prst="rect">
@@ -9219,7 +9354,7 @@
                 <a:ea typeface="Arial" pitchFamily="34" charset="-122"/>
                 <a:cs typeface="Arial" pitchFamily="34" charset="-120"/>
               </a:rPr>
-              <a:t>Des rôles qu'on réutilise</a:t>
+              <a:t>Trois rôles réutilisables</a:t>
             </a:r>
             <a:endParaRPr lang="en-US" sz="1300" dirty="0"/>
           </a:p>
@@ -9233,7 +9368,7 @@
         </p:nvSpPr>
         <p:spPr>
           <a:xfrm>
-            <a:off x="7543800" y="2359152"/>
+            <a:off x="7543800" y="2340864"/>
             <a:ext cx="3931920" cy="777240"/>
           </a:xfrm>
           <a:prstGeom prst="rect">
@@ -9258,7 +9393,7 @@
                 <a:ea typeface="Calibri" pitchFamily="34" charset="-122"/>
                 <a:cs typeface="Calibri" pitchFamily="34" charset="-120"/>
               </a:rPr>
-              <a:t>Le serveur d'entrée et les caisses partagent le même rôle de base, avec des réglages différents. Docker vient d'un rôle public, installé depuis Galaxy.</a:t>
+              <a:t>common, efs et prestashop. Le bastion et les serveurs applicatifs utilisent le même rôle common avec des variables différentes. Docker vient d'un rôle Ansible Galaxy.</a:t>
             </a:r>
             <a:endParaRPr lang="en-US" sz="1100" dirty="0"/>
           </a:p>
@@ -9272,7 +9407,7 @@
         </p:nvSpPr>
         <p:spPr>
           <a:xfrm>
-            <a:off x="7360920" y="3310128"/>
+            <a:off x="7360920" y="3291840"/>
             <a:ext cx="4261104" cy="1234440"/>
           </a:xfrm>
           <a:prstGeom prst="roundRect">
@@ -9299,7 +9434,7 @@
         </p:nvSpPr>
         <p:spPr>
           <a:xfrm>
-            <a:off x="7543800" y="3429000"/>
+            <a:off x="7543800" y="3410712"/>
             <a:ext cx="3931920" cy="274320"/>
           </a:xfrm>
           <a:prstGeom prst="rect">
@@ -9324,7 +9459,7 @@
                 <a:ea typeface="Arial" pitchFamily="34" charset="-122"/>
                 <a:cs typeface="Arial" pitchFamily="34" charset="-120"/>
               </a:rPr>
-              <a:t>Les secrets sont chiffrés</a:t>
+              <a:t>Secrets protégés</a:t>
             </a:r>
             <a:endParaRPr lang="en-US" sz="1300" dirty="0"/>
           </a:p>
@@ -9338,7 +9473,7 @@
         </p:nvSpPr>
         <p:spPr>
           <a:xfrm>
-            <a:off x="7543800" y="3730752"/>
+            <a:off x="7543800" y="3712464"/>
             <a:ext cx="3931920" cy="777240"/>
           </a:xfrm>
           <a:prstGeom prst="rect">
@@ -9363,7 +9498,7 @@
                 <a:ea typeface="Calibri" pitchFamily="34" charset="-122"/>
                 <a:cs typeface="Calibri" pitchFamily="34" charset="-120"/>
               </a:rPr>
-              <a:t>Le mot de passe de l'administration est chiffré dans le dépôt. Celui de la base n'y est même pas.</a:t>
+              <a:t>Les identifiants du back-office sont chiffrés avec Ansible Vault. Le mot de passe de la base n'est pas dans le dépôt.</a:t>
             </a:r>
             <a:endParaRPr lang="en-US" sz="1100" dirty="0"/>
           </a:p>
@@ -9377,7 +9512,7 @@
         </p:nvSpPr>
         <p:spPr>
           <a:xfrm>
-            <a:off x="7360920" y="4681728"/>
+            <a:off x="7360920" y="4663440"/>
             <a:ext cx="4261104" cy="1234440"/>
           </a:xfrm>
           <a:prstGeom prst="roundRect">
@@ -9404,7 +9539,7 @@
         </p:nvSpPr>
         <p:spPr>
           <a:xfrm>
-            <a:off x="7543800" y="4800600"/>
+            <a:off x="7543800" y="4782312"/>
             <a:ext cx="3931920" cy="274320"/>
           </a:xfrm>
           <a:prstGeom prst="rect">
@@ -9429,7 +9564,7 @@
                 <a:ea typeface="Arial" pitchFamily="34" charset="-122"/>
                 <a:cs typeface="Arial" pitchFamily="34" charset="-120"/>
               </a:rPr>
-              <a:t>On peut le relancer sans risque</a:t>
+              <a:t>Playbook idempotent</a:t>
             </a:r>
             <a:endParaRPr lang="en-US" sz="1300" dirty="0"/>
           </a:p>
@@ -9443,7 +9578,7 @@
         </p:nvSpPr>
         <p:spPr>
           <a:xfrm>
-            <a:off x="7543800" y="5102352"/>
+            <a:off x="7543800" y="5084064"/>
             <a:ext cx="3931920" cy="777240"/>
           </a:xfrm>
           <a:prstGeom prst="rect">
@@ -9468,7 +9603,7 @@
                 <a:ea typeface="Calibri" pitchFamily="34" charset="-122"/>
                 <a:cs typeface="Calibri" pitchFamily="34" charset="-120"/>
               </a:rPr>
-              <a:t>Ansible décrit l'état voulu, pas des étapes. Si tout est déjà en place, il ne touche à rien.</a:t>
+              <a:t>Le playbook décrit l'état voulu. Si l'état est déjà atteint, il ne modifie rien.</a:t>
             </a:r>
             <a:endParaRPr lang="en-US" sz="1100" dirty="0"/>
           </a:p>
@@ -9534,7 +9669,7 @@
                 <a:ea typeface="Arial" pitchFamily="34" charset="-122"/>
                 <a:cs typeface="Arial" pitchFamily="34" charset="-120"/>
               </a:rPr>
-              <a:t>On relance : « changed=0 »</a:t>
+              <a:t>Deuxième exécution : changed=0</a:t>
             </a:r>
             <a:endParaRPr lang="en-US" sz="1600" dirty="0"/>
           </a:p>
@@ -9573,7 +9708,7 @@
                 <a:ea typeface="Calibri" pitchFamily="34" charset="-122"/>
                 <a:cs typeface="Calibri" pitchFamily="34" charset="-120"/>
               </a:rPr>
-              <a:t>Zéro modification. La machine était déjà dans l'état demandé.</a:t>
+              <a:t>Aucune modification. Les serveurs sont déjà dans l'état décrit.</a:t>
             </a:r>
             <a:endParaRPr lang="en-US" sz="1250" dirty="0"/>
           </a:p>
@@ -9637,7 +9772,7 @@
                 <a:ea typeface="Courier New" pitchFamily="34" charset="-122"/>
                 <a:cs typeface="Courier New" pitchFamily="34" charset="-120"/>
               </a:rPr>
-              <a:t>06 — LE JOUR DE L'OUVERTURE</a:t>
+              <a:t>06 — MONTÉE EN CHARGE</a:t>
             </a:r>
             <a:endParaRPr lang="en-US" sz="1100" dirty="0"/>
           </a:p>
@@ -9676,7 +9811,7 @@
                 <a:ea typeface="Arial" pitchFamily="34" charset="-122"/>
                 <a:cs typeface="Arial" pitchFamily="34" charset="-120"/>
               </a:rPr>
-              <a:t>Plus de monde ? On change un chiffre</a:t>
+              <a:t>Ajouter des serveurs = modifier une variable</a:t>
             </a:r>
             <a:endParaRPr lang="en-US" sz="3000" dirty="0"/>
           </a:p>
@@ -9691,7 +9826,7 @@
         <p:spPr>
           <a:xfrm>
             <a:off x="566928" y="1463040"/>
-            <a:ext cx="10789920" cy="457200"/>
+            <a:ext cx="10789920" cy="365760"/>
           </a:xfrm>
           <a:prstGeom prst="rect">
             <a:avLst/>
@@ -9715,7 +9850,7 @@
                 <a:ea typeface="Calibri" pitchFamily="34" charset="-122"/>
                 <a:cs typeface="Calibri" pitchFamily="34" charset="-120"/>
               </a:rPr>
-              <a:t>Aucune commande, aucune image, aucun panier ne vit sur un serveur : tout est dans la base et sur le disque partagé. Du coup, ajouter un serveur ne dérange pas ceux qui travaillent déjà.</a:t>
+              <a:t>Les serveurs ne stockent aucune donnée. On peut donc en ajouter sans interrompre ceux qui répondent déjà.</a:t>
             </a:r>
             <a:endParaRPr lang="en-US" sz="1400" dirty="0"/>
           </a:p>
@@ -9729,7 +9864,7 @@
         </p:nvSpPr>
         <p:spPr>
           <a:xfrm>
-            <a:off x="566928" y="2148840"/>
+            <a:off x="566928" y="2103120"/>
             <a:ext cx="11055096" cy="1234440"/>
           </a:xfrm>
           <a:prstGeom prst="roundRect">
@@ -9756,7 +9891,7 @@
         </p:nvSpPr>
         <p:spPr>
           <a:xfrm>
-            <a:off x="731520" y="2258568"/>
+            <a:off x="731520" y="2212848"/>
             <a:ext cx="10725912" cy="1014984"/>
           </a:xfrm>
           <a:prstGeom prst="rect">
@@ -9784,7 +9919,7 @@
                 <a:ea typeface="Courier New" pitchFamily="34" charset="-122"/>
                 <a:cs typeface="Courier New" pitchFamily="34" charset="-120"/>
               </a:rPr>
-              <a:t>terraform apply -var app_instance_count=6      # on passe de 1 à 6 serveurs</a:t>
+              <a:t>terraform apply -var app_instance_count=6     # crée les serveurs</a:t>
             </a:r>
             <a:endParaRPr lang="en-US" sz="1250" dirty="0"/>
           </a:p>
@@ -9804,7 +9939,7 @@
                 <a:ea typeface="Courier New" pitchFamily="34" charset="-122"/>
                 <a:cs typeface="Courier New" pitchFamily="34" charset="-120"/>
               </a:rPr>
-              <a:t>ansible-playbook ... site.yml                  # on les installe</a:t>
+              <a:t>ansible-playbook ... site.yml                 # les configure</a:t>
             </a:r>
             <a:endParaRPr lang="en-US" sz="1250" dirty="0"/>
           </a:p>
@@ -9833,7 +9968,7 @@
                 <a:ea typeface="Courier New" pitchFamily="34" charset="-122"/>
                 <a:cs typeface="Courier New" pitchFamily="34" charset="-120"/>
               </a:rPr>
-              <a:t># environ 3 minutes, sans couper la boutique</a:t>
+              <a:t># environ 3 minutes, sans interruption de service</a:t>
             </a:r>
             <a:endParaRPr lang="en-US" sz="1250" dirty="0"/>
           </a:p>
@@ -9899,7 +10034,7 @@
                 <a:ea typeface="Courier New" pitchFamily="34" charset="-122"/>
                 <a:cs typeface="Courier New" pitchFamily="34" charset="-120"/>
               </a:rPr>
-              <a:t>AWS NOUS PRÉVIENT SI…</a:t>
+              <a:t>ALARME CLOUDWATCH</a:t>
             </a:r>
             <a:endParaRPr lang="en-US" sz="900" dirty="0"/>
           </a:p>
@@ -9938,7 +10073,7 @@
                 <a:ea typeface="Arial" pitchFamily="34" charset="-122"/>
                 <a:cs typeface="Arial" pitchFamily="34" charset="-120"/>
               </a:rPr>
-              <a:t>Le site devient lent</a:t>
+              <a:t>Temps de réponse &gt; 2 s</a:t>
             </a:r>
             <a:endParaRPr lang="en-US" sz="1400" dirty="0"/>
           </a:p>
@@ -9977,7 +10112,7 @@
                 <a:ea typeface="Calibri" pitchFamily="34" charset="-122"/>
                 <a:cs typeface="Calibri" pitchFamily="34" charset="-120"/>
               </a:rPr>
-              <a:t>Plus de 2 secondes de réponse pendant 3 minutes : la flotte sature, il faut ajouter des serveurs.</a:t>
+              <a:t>Moyenne sur 3 minutes. Signifie que les serveurs saturent : il faut en ajouter.</a:t>
             </a:r>
             <a:endParaRPr lang="en-US" sz="1150" dirty="0"/>
           </a:p>
@@ -10043,7 +10178,7 @@
                 <a:ea typeface="Courier New" pitchFamily="34" charset="-122"/>
                 <a:cs typeface="Courier New" pitchFamily="34" charset="-120"/>
               </a:rPr>
-              <a:t>AWS NOUS PRÉVIENT SI…</a:t>
+              <a:t>ALARME CLOUDWATCH</a:t>
             </a:r>
             <a:endParaRPr lang="en-US" sz="900" dirty="0"/>
           </a:p>
@@ -10082,7 +10217,7 @@
                 <a:ea typeface="Arial" pitchFamily="34" charset="-122"/>
                 <a:cs typeface="Arial" pitchFamily="34" charset="-120"/>
               </a:rPr>
-              <a:t>Un serveur ne répond plus</a:t>
+              <a:t>Serveur hors rotation</a:t>
             </a:r>
             <a:endParaRPr lang="en-US" sz="1400" dirty="0"/>
           </a:p>
@@ -10121,7 +10256,7 @@
                 <a:ea typeface="Calibri" pitchFamily="34" charset="-122"/>
                 <a:cs typeface="Calibri" pitchFamily="34" charset="-120"/>
               </a:rPr>
-              <a:t>Il est sorti tout seul de la rotation. On va voir pourquoi avant qu'il y en ait deux.</a:t>
+              <a:t>Le load balancer a retiré un serveur. Il faut comprendre pourquoi.</a:t>
             </a:r>
             <a:endParaRPr lang="en-US" sz="1150" dirty="0"/>
           </a:p>
@@ -10187,7 +10322,7 @@
                 <a:ea typeface="Courier New" pitchFamily="34" charset="-122"/>
                 <a:cs typeface="Courier New" pitchFamily="34" charset="-120"/>
               </a:rPr>
-              <a:t>AWS NOUS PRÉVIENT SI…</a:t>
+              <a:t>ALARME CLOUDWATCH</a:t>
             </a:r>
             <a:endParaRPr lang="en-US" sz="900" dirty="0"/>
           </a:p>
@@ -10226,7 +10361,7 @@
                 <a:ea typeface="Arial" pitchFamily="34" charset="-122"/>
                 <a:cs typeface="Arial" pitchFamily="34" charset="-120"/>
               </a:rPr>
-              <a:t>Le site renvoie des erreurs</a:t>
+              <a:t>Plus de 10 erreurs 5xx / min</a:t>
             </a:r>
             <a:endParaRPr lang="en-US" sz="1400" dirty="0"/>
           </a:p>
@@ -10265,7 +10400,7 @@
                 <a:ea typeface="Calibri" pitchFamily="34" charset="-122"/>
                 <a:cs typeface="Calibri" pitchFamily="34" charset="-120"/>
               </a:rPr>
-              <a:t>Plus de 10 erreurs par minute : la boutique répond, mais mal.</a:t>
+              <a:t>Les serveurs répondent, mais renvoient des erreurs.</a:t>
             </a:r>
             <a:endParaRPr lang="en-US" sz="1150" dirty="0"/>
           </a:p>
@@ -10329,7 +10464,7 @@
                 <a:ea typeface="Courier New" pitchFamily="34" charset="-122"/>
                 <a:cs typeface="Courier New" pitchFamily="34" charset="-120"/>
               </a:rPr>
-              <a:t>07 — QUAND ÇA CASSE</a:t>
+              <a:t>07 — PANNES</a:t>
             </a:r>
             <a:endParaRPr lang="en-US" sz="1100" dirty="0"/>
           </a:p>
@@ -10368,7 +10503,7 @@
                 <a:ea typeface="Arial" pitchFamily="34" charset="-122"/>
                 <a:cs typeface="Arial" pitchFamily="34" charset="-120"/>
               </a:rPr>
-              <a:t>On a chronométré chaque panne</a:t>
+              <a:t>Comportement mesuré en cas de panne</a:t>
             </a:r>
             <a:endParaRPr lang="en-US" sz="3000" dirty="0"/>
           </a:p>
@@ -10397,8 +10532,8 @@
             <a:tbl>
               <a:tblPr/>
               <a:tblGrid>
-                <a:gridCol w="2194560"/>
-                <a:gridCol w="5660136"/>
+                <a:gridCol w="2377440"/>
+                <a:gridCol w="5477256"/>
                 <a:gridCol w="1737360"/>
                 <a:gridCol w="1463040"/>
               </a:tblGrid>
@@ -10420,7 +10555,7 @@
                           <a:ea typeface="Calibri" pitchFamily="34" charset="-122"/>
                           <a:cs typeface="Calibri" pitchFamily="34" charset="-120"/>
                         </a:rPr>
-                        <a:t>CE QUI TOMBE</a:t>
+                        <a:t>PANNE</a:t>
                       </a:r>
                       <a:endParaRPr lang="en-US" sz="1250" dirty="0">
                         <a:latin typeface="Calibri" charset="0"/>
@@ -10488,7 +10623,7 @@
                           <a:ea typeface="Calibri" pitchFamily="34" charset="-122"/>
                           <a:cs typeface="Calibri" pitchFamily="34" charset="-120"/>
                         </a:rPr>
-                        <a:t>CE QUE VOIT LE CLIENT</a:t>
+                        <a:t>CONSÉQUENCE POUR LE CLIENT</a:t>
                       </a:r>
                       <a:endParaRPr lang="en-US" sz="1250" dirty="0">
                         <a:latin typeface="Calibri" charset="0"/>
@@ -10556,7 +10691,7 @@
                           <a:ea typeface="Calibri" pitchFamily="34" charset="-122"/>
                           <a:cs typeface="Calibri" pitchFamily="34" charset="-120"/>
                         </a:rPr>
-                        <a:t>TEMPS</a:t>
+                        <a:t>DURÉE</a:t>
                       </a:r>
                       <a:endParaRPr lang="en-US" sz="1250" dirty="0">
                         <a:latin typeface="Calibri" charset="0"/>
@@ -10624,7 +10759,7 @@
                           <a:ea typeface="Calibri" pitchFamily="34" charset="-122"/>
                           <a:cs typeface="Calibri" pitchFamily="34" charset="-120"/>
                         </a:rPr>
-                        <a:t>ON INTERVIENT ?</a:t>
+                        <a:t>ACTION</a:t>
                       </a:r>
                       <a:endParaRPr lang="en-US" sz="1250" dirty="0">
                         <a:latin typeface="Calibri" charset="0"/>
@@ -10762,7 +10897,7 @@
                           <a:ea typeface="Calibri" pitchFamily="34" charset="-122"/>
                           <a:cs typeface="Calibri" pitchFamily="34" charset="-120"/>
                         </a:rPr>
-                        <a:t>Rien. Il est sorti de la rotation en 30 secondes, et les achats en cours ont le temps de se terminer.</a:t>
+                        <a:t>Aucune. Retiré de la rotation après 2 vérifications échouées, les requêtes en cours ont 30 s pour finir.</a:t>
                       </a:r>
                       <a:endParaRPr lang="en-US" sz="1250" dirty="0">
                         <a:latin typeface="Calibri" charset="0"/>
@@ -10898,7 +11033,7 @@
                           <a:ea typeface="Calibri" pitchFamily="34" charset="-122"/>
                           <a:cs typeface="Calibri" pitchFamily="34" charset="-120"/>
                         </a:rPr>
-                        <a:t>non</a:t>
+                        <a:t>aucune</a:t>
                       </a:r>
                       <a:endParaRPr lang="en-US" sz="1250" dirty="0">
                         <a:latin typeface="Calibri" charset="0"/>
@@ -10968,7 +11103,7 @@
                           <a:ea typeface="Calibri" pitchFamily="34" charset="-122"/>
                           <a:cs typeface="Calibri" pitchFamily="34" charset="-120"/>
                         </a:rPr>
-                        <a:t>Une zone AWS entière</a:t>
+                        <a:t>Une zone de disponibilité</a:t>
                       </a:r>
                       <a:endParaRPr lang="en-US" sz="1250" dirty="0">
                         <a:latin typeface="Calibri" charset="0"/>
@@ -11036,7 +11171,7 @@
                           <a:ea typeface="Calibri" pitchFamily="34" charset="-122"/>
                           <a:cs typeface="Calibri" pitchFamily="34" charset="-120"/>
                         </a:rPr>
-                        <a:t>Rien. Les serveurs des autres zones prennent le relais.</a:t>
+                        <a:t>Aucune. Les serveurs des autres zones prennent le relais.</a:t>
                       </a:r>
                       <a:endParaRPr lang="en-US" sz="1250" dirty="0">
                         <a:latin typeface="Calibri" charset="0"/>
@@ -11172,7 +11307,7 @@
                           <a:ea typeface="Calibri" pitchFamily="34" charset="-122"/>
                           <a:cs typeface="Calibri" pitchFamily="34" charset="-120"/>
                         </a:rPr>
-                        <a:t>non</a:t>
+                        <a:t>aucune</a:t>
                       </a:r>
                       <a:endParaRPr lang="en-US" sz="1250" dirty="0">
                         <a:latin typeface="Calibri" charset="0"/>
@@ -11310,7 +11445,7 @@
                           <a:ea typeface="Calibri" pitchFamily="34" charset="-122"/>
                           <a:cs typeface="Calibri" pitchFamily="34" charset="-120"/>
                         </a:rPr>
-                        <a:t>Quelques secondes d'erreur, puis ça repart sur la machine de secours.</a:t>
+                        <a:t>Erreurs pendant le basculement, puis retour à la normale sur l'instance de secours.</a:t>
                       </a:r>
                       <a:endParaRPr lang="en-US" sz="1250" dirty="0">
                         <a:latin typeface="Calibri" charset="0"/>
@@ -11378,7 +11513,7 @@
                           <a:ea typeface="Calibri" pitchFamily="34" charset="-122"/>
                           <a:cs typeface="Calibri" pitchFamily="34" charset="-120"/>
                         </a:rPr>
-                        <a:t>1 à 2 min</a:t>
+                        <a:t>60 à 120 s</a:t>
                       </a:r>
                       <a:endParaRPr lang="en-US" sz="1250" dirty="0">
                         <a:latin typeface="Calibri" charset="0"/>
@@ -11446,7 +11581,7 @@
                           <a:ea typeface="Calibri" pitchFamily="34" charset="-122"/>
                           <a:cs typeface="Calibri" pitchFamily="34" charset="-120"/>
                         </a:rPr>
-                        <a:t>non (en prod)</a:t>
+                        <a:t>aucune (prod)</a:t>
                       </a:r>
                       <a:endParaRPr lang="en-US" sz="1250" dirty="0">
                         <a:latin typeface="Calibri" charset="0"/>
@@ -11516,7 +11651,7 @@
                           <a:ea typeface="Calibri" pitchFamily="34" charset="-122"/>
                           <a:cs typeface="Calibri" pitchFamily="34" charset="-120"/>
                         </a:rPr>
-                        <a:t>Notre serveur d'entrée</a:t>
+                        <a:t>Le bastion</a:t>
                       </a:r>
                       <a:endParaRPr lang="en-US" sz="1250" dirty="0">
                         <a:latin typeface="Calibri" charset="0"/>
@@ -11584,7 +11719,7 @@
                           <a:ea typeface="Calibri" pitchFamily="34" charset="-122"/>
                           <a:cs typeface="Calibri" pitchFamily="34" charset="-120"/>
                         </a:rPr>
-                        <a:t>Rien du tout : aucun client ne passe par là.</a:t>
+                        <a:t>Aucune. Il ne sert qu'à l'administration.</a:t>
                       </a:r>
                       <a:endParaRPr lang="en-US" sz="1250" dirty="0">
                         <a:latin typeface="Calibri" charset="0"/>
@@ -11720,7 +11855,7 @@
                           <a:ea typeface="Calibri" pitchFamily="34" charset="-122"/>
                           <a:cs typeface="Calibri" pitchFamily="34" charset="-120"/>
                         </a:rPr>
-                        <a:t>on le recrée</a:t>
+                        <a:t>le recréer</a:t>
                       </a:r>
                       <a:endParaRPr lang="en-US" sz="1250" dirty="0">
                         <a:latin typeface="Calibri" charset="0"/>
@@ -11785,11 +11920,11 @@
         <p:spPr>
           <a:xfrm>
             <a:off x="566928" y="4892040"/>
-            <a:ext cx="11055096" cy="868680"/>
+            <a:ext cx="11055096" cy="822960"/>
           </a:xfrm>
           <a:prstGeom prst="roundRect">
             <a:avLst>
-              <a:gd name="adj" fmla="val 5263"/>
+              <a:gd name="adj" fmla="val 5556"/>
             </a:avLst>
           </a:prstGeom>
           <a:solidFill>
@@ -11811,24 +11946,24 @@
         </p:nvSpPr>
         <p:spPr>
           <a:xfrm>
-            <a:off x="822960" y="5029200"/>
-            <a:ext cx="10543032" cy="640080"/>
-          </a:xfrm>
-          <a:prstGeom prst="rect">
-            <a:avLst/>
-          </a:prstGeom>
-          <a:noFill/>
-          <a:ln/>
-        </p:spPr>
-        <p:txBody>
-          <a:bodyPr wrap="square" lIns="0" tIns="0" rIns="0" bIns="0" rtlCol="0" anchor="ctr"/>
-          <a:lstStyle/>
-          <a:p>
-            <a:pPr indent="0" marL="0">
-              <a:buNone/>
-            </a:pPr>
-            <a:r>
-              <a:rPr lang="en-US" sz="1350" dirty="0">
+            <a:off x="822960" y="5047488"/>
+            <a:ext cx="10543032" cy="548640"/>
+          </a:xfrm>
+          <a:prstGeom prst="rect">
+            <a:avLst/>
+          </a:prstGeom>
+          <a:noFill/>
+          <a:ln/>
+        </p:spPr>
+        <p:txBody>
+          <a:bodyPr wrap="square" lIns="0" tIns="0" rIns="0" bIns="0" rtlCol="0" anchor="ctr"/>
+          <a:lstStyle/>
+          <a:p>
+            <a:pPr indent="0" marL="0">
+              <a:buNone/>
+            </a:pPr>
+            <a:r>
+              <a:rPr lang="en-US" sz="1400" b="1" dirty="0">
                 <a:solidFill>
                   <a:srgbClr val="17222C"/>
                 </a:solidFill>
@@ -11836,9 +11971,9 @@
                 <a:ea typeface="Calibri" pitchFamily="34" charset="-122"/>
                 <a:cs typeface="Calibri" pitchFamily="34" charset="-120"/>
               </a:rPr>
-              <a:t>Et surtout : le panier du client est conservé. Les paniers sont sur le disque partagé, pas sur le serveur qui tombe. C'est la différence entre « un serveur est tombé » et « mon panier est vide ».</a:t>
-            </a:r>
-            <a:endParaRPr lang="en-US" sz="1350" dirty="0"/>
+              <a:t>Le panier du client est conservé : les sessions PHP sont sur le disque partagé, pas sur le serveur en panne.</a:t>
+            </a:r>
+            <a:endParaRPr lang="en-US" sz="1400" dirty="0"/>
           </a:p>
         </p:txBody>
       </p:sp>
@@ -11900,7 +12035,7 @@
                 <a:ea typeface="Courier New" pitchFamily="34" charset="-122"/>
                 <a:cs typeface="Courier New" pitchFamily="34" charset="-120"/>
               </a:rPr>
-              <a:t>08 — CE QU'ON A APPRIS</a:t>
+              <a:t>08 — PROBLÈMES RENCONTRÉS</a:t>
             </a:r>
             <a:endParaRPr lang="en-US" sz="1100" dirty="0"/>
           </a:p>
@@ -11939,7 +12074,7 @@
                 <a:ea typeface="Arial" pitchFamily="34" charset="-122"/>
                 <a:cs typeface="Arial" pitchFamily="34" charset="-120"/>
               </a:rPr>
-              <a:t>Quatre problèmes vus seulement en vrai</a:t>
+              <a:t>Quatre erreurs apparues au déploiement réel</a:t>
             </a:r>
             <a:endParaRPr lang="en-US" sz="3000" dirty="0"/>
           </a:p>
@@ -12069,7 +12204,7 @@
                 <a:ea typeface="Arial" pitchFamily="34" charset="-122"/>
                 <a:cs typeface="Arial" pitchFamily="34" charset="-120"/>
               </a:rPr>
-              <a:t>Un caractère interdit</a:t>
+              <a:t>Caractère refusé par AWS</a:t>
             </a:r>
             <a:endParaRPr lang="en-US" sz="1500" dirty="0"/>
           </a:p>
@@ -12100,7 +12235,7 @@
               <a:buNone/>
             </a:pPr>
             <a:r>
-              <a:rPr lang="en-US" sz="1250" dirty="0">
+              <a:rPr lang="en-US" sz="1200" dirty="0">
                 <a:solidFill>
                   <a:srgbClr val="5C6B7A"/>
                 </a:solidFill>
@@ -12108,9 +12243,9 @@
                 <a:ea typeface="Calibri" pitchFamily="34" charset="-122"/>
                 <a:cs typeface="Calibri" pitchFamily="34" charset="-120"/>
               </a:rPr>
-              <a:t>AWS refuse certains caractères dans les descriptions. On avait écrit une flèche « -&gt; ». Création refusée.</a:t>
-            </a:r>
-            <a:endParaRPr lang="en-US" sz="1250" dirty="0"/>
+              <a:t>AWS n'accepte qu'un jeu de caractères limité dans les descriptions de groupes de sécurité. Le caractère « &gt; » que nous avions utilisé faisait échouer la création.</a:t>
+            </a:r>
+            <a:endParaRPr lang="en-US" sz="1200" dirty="0"/>
           </a:p>
         </p:txBody>
       </p:sp>
@@ -12238,7 +12373,7 @@
                 <a:ea typeface="Arial" pitchFamily="34" charset="-122"/>
                 <a:cs typeface="Arial" pitchFamily="34" charset="-120"/>
               </a:rPr>
-              <a:t>Un outil qui n'existe plus</a:t>
+              <a:t>Paquet awscli inexistant</a:t>
             </a:r>
             <a:endParaRPr lang="en-US" sz="1500" dirty="0"/>
           </a:p>
@@ -12269,7 +12404,7 @@
               <a:buNone/>
             </a:pPr>
             <a:r>
-              <a:rPr lang="en-US" sz="1250" dirty="0">
+              <a:rPr lang="en-US" sz="1200" dirty="0">
                 <a:solidFill>
                   <a:srgbClr val="5C6B7A"/>
                 </a:solidFill>
@@ -12277,9 +12412,9 @@
                 <a:ea typeface="Calibri" pitchFamily="34" charset="-122"/>
                 <a:cs typeface="Calibri" pitchFamily="34" charset="-120"/>
               </a:rPr>
-              <a:t>Le paquet awscli a disparu d'Ubuntu 24.04. On est passés à une bibliothèque Python : 60 Mo de moins par serveur.</a:t>
-            </a:r>
-            <a:endParaRPr lang="en-US" sz="1250" dirty="0"/>
+              <a:t>Le paquet a été retiré des dépôts d'Ubuntu 24.04. Nous l'avons remplacé par la bibliothèque Python boto3, déjà disponible dans les dépôts de base.</a:t>
+            </a:r>
+            <a:endParaRPr lang="en-US" sz="1200" dirty="0"/>
           </a:p>
         </p:txBody>
       </p:sp>
@@ -12407,7 +12542,7 @@
                 <a:ea typeface="Arial" pitchFamily="34" charset="-122"/>
                 <a:cs typeface="Arial" pitchFamily="34" charset="-120"/>
               </a:rPr>
-              <a:t>Un mot de passe exécuté</a:t>
+              <a:t>Mot de passe interprété</a:t>
             </a:r>
             <a:endParaRPr lang="en-US" sz="1500" dirty="0"/>
           </a:p>
@@ -12438,7 +12573,7 @@
               <a:buNone/>
             </a:pPr>
             <a:r>
-              <a:rPr lang="en-US" sz="1250" dirty="0">
+              <a:rPr lang="en-US" sz="1200" dirty="0">
                 <a:solidFill>
                   <a:srgbClr val="5C6B7A"/>
                 </a:solidFill>
@@ -12446,9 +12581,9 @@
                 <a:ea typeface="Calibri" pitchFamily="34" charset="-122"/>
                 <a:cs typeface="Calibri" pitchFamily="34" charset="-120"/>
               </a:rPr>
-              <a:t>Le mot de passe généré contenait un « &amp; ». Le shell a cru que c'était une commande et a essayé de l'exécuter.</a:t>
-            </a:r>
-            <a:endParaRPr lang="en-US" sz="1250" dirty="0"/>
+              <a:t>Le script chargeait le fichier d'environnement avec « source ». Le mot de passe généré contenait un « &amp; », que le shell a interprété comme une commande.</a:t>
+            </a:r>
+            <a:endParaRPr lang="en-US" sz="1200" dirty="0"/>
           </a:p>
         </p:txBody>
       </p:sp>
@@ -12576,7 +12711,7 @@
                 <a:ea typeface="Arial" pitchFamily="34" charset="-122"/>
                 <a:cs typeface="Arial" pitchFamily="34" charset="-120"/>
               </a:rPr>
-              <a:t>Un cache incompatible</a:t>
+              <a:t>Cache incompatible avec NFS</a:t>
             </a:r>
             <a:endParaRPr lang="en-US" sz="1500" dirty="0"/>
           </a:p>
@@ -12607,7 +12742,7 @@
               <a:buNone/>
             </a:pPr>
             <a:r>
-              <a:rPr lang="en-US" sz="1250" dirty="0">
+              <a:rPr lang="en-US" sz="1200" dirty="0">
                 <a:solidFill>
                   <a:srgbClr val="5C6B7A"/>
                 </a:solidFill>
@@ -12615,9 +12750,9 @@
                 <a:ea typeface="Calibri" pitchFamily="34" charset="-122"/>
                 <a:cs typeface="Calibri" pitchFamily="34" charset="-120"/>
               </a:rPr>
-              <a:t>Sur un disque partagé, PrestaShop n'arrivait pas à vider son cache. On l'a remis sur le disque local du serveur.</a:t>
-            </a:r>
-            <a:endParaRPr lang="en-US" sz="1250" dirty="0"/>
+              <a:t>Sur un disque réseau, supprimer un fichier ouvert laisse une trace. Le vidage de cache de PrestaShop échouait. Le cache est passé sur le disque local.</a:t>
+            </a:r>
+            <a:endParaRPr lang="en-US" sz="1200" dirty="0"/>
           </a:p>
         </p:txBody>
       </p:sp>
@@ -12646,7 +12781,7 @@
               <a:buNone/>
             </a:pPr>
             <a:r>
-              <a:rPr lang="en-US" sz="1500" i="1" dirty="0">
+              <a:rPr lang="en-US" sz="1500" b="1" dirty="0">
                 <a:solidFill>
                   <a:srgbClr val="9E5D06"/>
                 </a:solidFill>
@@ -12654,7 +12789,7 @@
                 <a:ea typeface="Calibri" pitchFamily="34" charset="-122"/>
                 <a:cs typeface="Calibri" pitchFamily="34" charset="-120"/>
               </a:rPr>
-              <a:t>Les quatre sont corrigés dans le dépôt : un déploiement depuis zéro ne les rencontre plus.</a:t>
+              <a:t>Les quatre corrections sont dans le dépôt. Un déploiement depuis zéro ne les rencontre plus.</a:t>
             </a:r>
             <a:endParaRPr lang="en-US" sz="1500" dirty="0"/>
           </a:p>

</xml_diff>

<commit_message>
docs: diapositives de titre et de bilan en fond blanc
Les deux diapositives a fond sombre s'affichaient illisibles sous
OpenOffice. Elles passent en fond blanc avec texte fonce, comme les
quatre autres : le support est desormais uniformement clair.

Co-Authored-By: Claude Opus 5 <noreply@anthropic.com>
Claude-Session: https://claude.ai/code/session_018ABZHHV3NVYucierxWNFBR
</commit_message>
<xml_diff>
--- a/docs/soutenance-5hash.pptx
+++ b/docs/soutenance-5hash.pptx
@@ -1337,7 +1337,7 @@
     <p:bg>
       <p:bgPr>
         <a:solidFill>
-          <a:srgbClr val="0F1720"/>
+          <a:srgbClr val="FFFFFF"/>
         </a:solidFill>
       </p:bgPr>
     </p:bg>
@@ -1407,7 +1407,7 @@
             <a:r>
               <a:rPr lang="en-US" sz="1200" spc="200" kern="0" dirty="0">
                 <a:solidFill>
-                  <a:srgbClr val="E08B1F"/>
+                  <a:srgbClr val="9E5D06"/>
                 </a:solidFill>
                 <a:latin typeface="Courier New" pitchFamily="34" charset="0"/>
                 <a:ea typeface="Courier New" pitchFamily="34" charset="-122"/>
@@ -1446,7 +1446,7 @@
             <a:r>
               <a:rPr lang="en-US" sz="5600" b="1" dirty="0">
                 <a:solidFill>
-                  <a:srgbClr val="FFFFFF"/>
+                  <a:srgbClr val="17222C"/>
                 </a:solidFill>
                 <a:latin typeface="Arial" pitchFamily="34" charset="0"/>
                 <a:ea typeface="Arial" pitchFamily="34" charset="-122"/>
@@ -1485,7 +1485,7 @@
             <a:r>
               <a:rPr lang="en-US" sz="2100" dirty="0">
                 <a:solidFill>
-                  <a:srgbClr val="A8B8C8"/>
+                  <a:srgbClr val="5C6B7A"/>
                 </a:solidFill>
                 <a:latin typeface="Calibri" pitchFamily="34" charset="0"/>
                 <a:ea typeface="Calibri" pitchFamily="34" charset="-122"/>
@@ -1514,11 +1514,11 @@
             </a:avLst>
           </a:prstGeom>
           <a:solidFill>
-            <a:srgbClr val="1B2732"/>
+            <a:srgbClr val="F2F5F7"/>
           </a:solidFill>
           <a:ln w="9525">
             <a:solidFill>
-              <a:srgbClr val="35475A"/>
+              <a:srgbClr val="D3DBE3"/>
             </a:solidFill>
             <a:prstDash val="solid"/>
           </a:ln>
@@ -1551,7 +1551,7 @@
             <a:r>
               <a:rPr lang="en-US" sz="1200" dirty="0">
                 <a:solidFill>
-                  <a:srgbClr val="C9D6E2"/>
+                  <a:srgbClr val="17222C"/>
                 </a:solidFill>
                 <a:latin typeface="Courier New" pitchFamily="34" charset="0"/>
                 <a:ea typeface="Courier New" pitchFamily="34" charset="-122"/>
@@ -1580,11 +1580,11 @@
             </a:avLst>
           </a:prstGeom>
           <a:solidFill>
-            <a:srgbClr val="1B2732"/>
+            <a:srgbClr val="F2F5F7"/>
           </a:solidFill>
           <a:ln w="9525">
             <a:solidFill>
-              <a:srgbClr val="35475A"/>
+              <a:srgbClr val="D3DBE3"/>
             </a:solidFill>
             <a:prstDash val="solid"/>
           </a:ln>
@@ -1617,7 +1617,7 @@
             <a:r>
               <a:rPr lang="en-US" sz="1200" dirty="0">
                 <a:solidFill>
-                  <a:srgbClr val="C9D6E2"/>
+                  <a:srgbClr val="17222C"/>
                 </a:solidFill>
                 <a:latin typeface="Courier New" pitchFamily="34" charset="0"/>
                 <a:ea typeface="Courier New" pitchFamily="34" charset="-122"/>
@@ -1646,11 +1646,11 @@
             </a:avLst>
           </a:prstGeom>
           <a:solidFill>
-            <a:srgbClr val="1B2732"/>
+            <a:srgbClr val="F2F5F7"/>
           </a:solidFill>
           <a:ln w="9525">
             <a:solidFill>
-              <a:srgbClr val="35475A"/>
+              <a:srgbClr val="D3DBE3"/>
             </a:solidFill>
             <a:prstDash val="solid"/>
           </a:ln>
@@ -1683,7 +1683,7 @@
             <a:r>
               <a:rPr lang="en-US" sz="1200" dirty="0">
                 <a:solidFill>
-                  <a:srgbClr val="C9D6E2"/>
+                  <a:srgbClr val="17222C"/>
                 </a:solidFill>
                 <a:latin typeface="Courier New" pitchFamily="34" charset="0"/>
                 <a:ea typeface="Courier New" pitchFamily="34" charset="-122"/>
@@ -1712,11 +1712,11 @@
             </a:avLst>
           </a:prstGeom>
           <a:solidFill>
-            <a:srgbClr val="1B2732"/>
+            <a:srgbClr val="F2F5F7"/>
           </a:solidFill>
           <a:ln w="9525">
             <a:solidFill>
-              <a:srgbClr val="35475A"/>
+              <a:srgbClr val="D3DBE3"/>
             </a:solidFill>
             <a:prstDash val="solid"/>
           </a:ln>
@@ -1749,7 +1749,7 @@
             <a:r>
               <a:rPr lang="en-US" sz="1200" dirty="0">
                 <a:solidFill>
-                  <a:srgbClr val="C9D6E2"/>
+                  <a:srgbClr val="17222C"/>
                 </a:solidFill>
                 <a:latin typeface="Courier New" pitchFamily="34" charset="0"/>
                 <a:ea typeface="Courier New" pitchFamily="34" charset="-122"/>
@@ -1788,7 +1788,7 @@
             <a:r>
               <a:rPr lang="en-US" sz="1600" dirty="0">
                 <a:solidFill>
-                  <a:srgbClr val="FFFFFF"/>
+                  <a:srgbClr val="17222C"/>
                 </a:solidFill>
                 <a:latin typeface="Calibri" pitchFamily="34" charset="0"/>
                 <a:ea typeface="Calibri" pitchFamily="34" charset="-122"/>
@@ -1827,7 +1827,7 @@
             <a:r>
               <a:rPr lang="en-US" sz="1300" dirty="0">
                 <a:solidFill>
-                  <a:srgbClr val="7A8C9E"/>
+                  <a:srgbClr val="5C6B7A"/>
                 </a:solidFill>
                 <a:latin typeface="Calibri" pitchFamily="34" charset="0"/>
                 <a:ea typeface="Calibri" pitchFamily="34" charset="-122"/>
@@ -1856,11 +1856,11 @@
             </a:avLst>
           </a:prstGeom>
           <a:solidFill>
-            <a:srgbClr val="1B2732"/>
+            <a:srgbClr val="F2F5F7"/>
           </a:solidFill>
           <a:ln w="9525">
             <a:solidFill>
-              <a:srgbClr val="35475A"/>
+              <a:srgbClr val="D3DBE3"/>
             </a:solidFill>
             <a:prstDash val="solid"/>
           </a:ln>
@@ -1893,7 +1893,7 @@
             <a:r>
               <a:rPr lang="en-US" sz="1250" dirty="0">
                 <a:solidFill>
-                  <a:srgbClr val="C9D6E2"/>
+                  <a:srgbClr val="17222C"/>
                 </a:solidFill>
                 <a:latin typeface="Courier New" pitchFamily="34" charset="0"/>
                 <a:ea typeface="Courier New" pitchFamily="34" charset="-122"/>
@@ -7231,7 +7231,7 @@
     <p:bg>
       <p:bgPr>
         <a:solidFill>
-          <a:srgbClr val="0F1720"/>
+          <a:srgbClr val="FFFFFF"/>
         </a:solidFill>
       </p:bgPr>
     </p:bg>
@@ -7301,7 +7301,7 @@
             <a:r>
               <a:rPr lang="en-US" sz="1200" spc="200" kern="0" dirty="0">
                 <a:solidFill>
-                  <a:srgbClr val="E08B1F"/>
+                  <a:srgbClr val="9E5D06"/>
                 </a:solidFill>
                 <a:latin typeface="Courier New" pitchFamily="34" charset="0"/>
                 <a:ea typeface="Courier New" pitchFamily="34" charset="-122"/>
@@ -7340,7 +7340,7 @@
             <a:r>
               <a:rPr lang="en-US" sz="3400" b="1" dirty="0">
                 <a:solidFill>
-                  <a:srgbClr val="FFFFFF"/>
+                  <a:srgbClr val="17222C"/>
                 </a:solidFill>
                 <a:latin typeface="Arial" pitchFamily="34" charset="0"/>
                 <a:ea typeface="Arial" pitchFamily="34" charset="-122"/>
@@ -7369,11 +7369,11 @@
             </a:avLst>
           </a:prstGeom>
           <a:solidFill>
-            <a:srgbClr val="1B2732"/>
+            <a:srgbClr val="FFFFFF"/>
           </a:solidFill>
           <a:ln w="9525">
             <a:solidFill>
-              <a:srgbClr val="35475A"/>
+              <a:srgbClr val="D3DBE3"/>
             </a:solidFill>
             <a:prstDash val="solid"/>
           </a:ln>
@@ -7468,7 +7468,7 @@
             <a:r>
               <a:rPr lang="en-US" sz="1050" dirty="0">
                 <a:solidFill>
-                  <a:srgbClr val="C9D6E2"/>
+                  <a:srgbClr val="17222C"/>
                 </a:solidFill>
                 <a:latin typeface="Calibri" pitchFamily="34" charset="0"/>
                 <a:ea typeface="Calibri" pitchFamily="34" charset="-122"/>
@@ -7507,7 +7507,7 @@
             <a:r>
               <a:rPr lang="en-US" sz="1050" dirty="0">
                 <a:solidFill>
-                  <a:srgbClr val="C9D6E2"/>
+                  <a:srgbClr val="17222C"/>
                 </a:solidFill>
                 <a:latin typeface="Calibri" pitchFamily="34" charset="0"/>
                 <a:ea typeface="Calibri" pitchFamily="34" charset="-122"/>
@@ -7546,7 +7546,7 @@
             <a:r>
               <a:rPr lang="en-US" sz="1050" dirty="0">
                 <a:solidFill>
-                  <a:srgbClr val="C9D6E2"/>
+                  <a:srgbClr val="17222C"/>
                 </a:solidFill>
                 <a:latin typeface="Calibri" pitchFamily="34" charset="0"/>
                 <a:ea typeface="Calibri" pitchFamily="34" charset="-122"/>
@@ -7585,7 +7585,7 @@
             <a:r>
               <a:rPr lang="en-US" sz="1050" dirty="0">
                 <a:solidFill>
-                  <a:srgbClr val="C9D6E2"/>
+                  <a:srgbClr val="17222C"/>
                 </a:solidFill>
                 <a:latin typeface="Calibri" pitchFamily="34" charset="0"/>
                 <a:ea typeface="Calibri" pitchFamily="34" charset="-122"/>
@@ -7614,11 +7614,11 @@
             </a:avLst>
           </a:prstGeom>
           <a:solidFill>
-            <a:srgbClr val="1B2732"/>
+            <a:srgbClr val="FFFFFF"/>
           </a:solidFill>
           <a:ln w="9525">
             <a:solidFill>
-              <a:srgbClr val="35475A"/>
+              <a:srgbClr val="D3DBE3"/>
             </a:solidFill>
             <a:prstDash val="solid"/>
           </a:ln>
@@ -7641,7 +7641,7 @@
           <a:noFill/>
           <a:ln w="25400">
             <a:solidFill>
-              <a:srgbClr val="E08B1F"/>
+              <a:srgbClr val="9E5D06"/>
             </a:solidFill>
             <a:prstDash val="solid"/>
           </a:ln>
@@ -7674,7 +7674,7 @@
             <a:r>
               <a:rPr lang="en-US" sz="1000" b="1" spc="50" kern="0" dirty="0">
                 <a:solidFill>
-                  <a:srgbClr val="E08B1F"/>
+                  <a:srgbClr val="9E5D06"/>
                 </a:solidFill>
                 <a:latin typeface="Courier New" pitchFamily="34" charset="0"/>
                 <a:ea typeface="Courier New" pitchFamily="34" charset="-122"/>
@@ -7713,7 +7713,7 @@
             <a:r>
               <a:rPr lang="en-US" sz="1050" dirty="0">
                 <a:solidFill>
-                  <a:srgbClr val="C9D6E2"/>
+                  <a:srgbClr val="17222C"/>
                 </a:solidFill>
                 <a:latin typeface="Calibri" pitchFamily="34" charset="0"/>
                 <a:ea typeface="Calibri" pitchFamily="34" charset="-122"/>
@@ -7752,7 +7752,7 @@
             <a:r>
               <a:rPr lang="en-US" sz="1050" dirty="0">
                 <a:solidFill>
-                  <a:srgbClr val="C9D6E2"/>
+                  <a:srgbClr val="17222C"/>
                 </a:solidFill>
                 <a:latin typeface="Calibri" pitchFamily="34" charset="0"/>
                 <a:ea typeface="Calibri" pitchFamily="34" charset="-122"/>
@@ -7791,7 +7791,7 @@
             <a:r>
               <a:rPr lang="en-US" sz="1050" dirty="0">
                 <a:solidFill>
-                  <a:srgbClr val="C9D6E2"/>
+                  <a:srgbClr val="17222C"/>
                 </a:solidFill>
                 <a:latin typeface="Calibri" pitchFamily="34" charset="0"/>
                 <a:ea typeface="Calibri" pitchFamily="34" charset="-122"/>
@@ -7830,7 +7830,7 @@
             <a:r>
               <a:rPr lang="en-US" sz="1050" dirty="0">
                 <a:solidFill>
-                  <a:srgbClr val="C9D6E2"/>
+                  <a:srgbClr val="17222C"/>
                 </a:solidFill>
                 <a:latin typeface="Calibri" pitchFamily="34" charset="0"/>
                 <a:ea typeface="Calibri" pitchFamily="34" charset="-122"/>
@@ -7859,11 +7859,11 @@
             </a:avLst>
           </a:prstGeom>
           <a:solidFill>
-            <a:srgbClr val="1B2732"/>
+            <a:srgbClr val="FFFFFF"/>
           </a:solidFill>
           <a:ln w="9525">
             <a:solidFill>
-              <a:srgbClr val="35475A"/>
+              <a:srgbClr val="D3DBE3"/>
             </a:solidFill>
             <a:prstDash val="solid"/>
           </a:ln>
@@ -7886,7 +7886,7 @@
           <a:noFill/>
           <a:ln w="25400">
             <a:solidFill>
-              <a:srgbClr val="8FA3B5"/>
+              <a:srgbClr val="5C6B7A"/>
             </a:solidFill>
             <a:prstDash val="solid"/>
           </a:ln>
@@ -7919,7 +7919,7 @@
             <a:r>
               <a:rPr lang="en-US" sz="1000" b="1" spc="50" kern="0" dirty="0">
                 <a:solidFill>
-                  <a:srgbClr val="8FA3B5"/>
+                  <a:srgbClr val="5C6B7A"/>
                 </a:solidFill>
                 <a:latin typeface="Courier New" pitchFamily="34" charset="0"/>
                 <a:ea typeface="Courier New" pitchFamily="34" charset="-122"/>
@@ -7958,7 +7958,7 @@
             <a:r>
               <a:rPr lang="en-US" sz="1050" dirty="0">
                 <a:solidFill>
-                  <a:srgbClr val="C9D6E2"/>
+                  <a:srgbClr val="17222C"/>
                 </a:solidFill>
                 <a:latin typeface="Calibri" pitchFamily="34" charset="0"/>
                 <a:ea typeface="Calibri" pitchFamily="34" charset="-122"/>
@@ -7997,7 +7997,7 @@
             <a:r>
               <a:rPr lang="en-US" sz="1050" dirty="0">
                 <a:solidFill>
-                  <a:srgbClr val="C9D6E2"/>
+                  <a:srgbClr val="17222C"/>
                 </a:solidFill>
                 <a:latin typeface="Calibri" pitchFamily="34" charset="0"/>
                 <a:ea typeface="Calibri" pitchFamily="34" charset="-122"/>
@@ -8036,7 +8036,7 @@
             <a:r>
               <a:rPr lang="en-US" sz="1050" dirty="0">
                 <a:solidFill>
-                  <a:srgbClr val="C9D6E2"/>
+                  <a:srgbClr val="17222C"/>
                 </a:solidFill>
                 <a:latin typeface="Calibri" pitchFamily="34" charset="0"/>
                 <a:ea typeface="Calibri" pitchFamily="34" charset="-122"/>
@@ -8075,7 +8075,7 @@
             <a:r>
               <a:rPr lang="en-US" sz="1050" dirty="0">
                 <a:solidFill>
-                  <a:srgbClr val="C9D6E2"/>
+                  <a:srgbClr val="17222C"/>
                 </a:solidFill>
                 <a:latin typeface="Calibri" pitchFamily="34" charset="0"/>
                 <a:ea typeface="Calibri" pitchFamily="34" charset="-122"/>
@@ -8114,7 +8114,7 @@
             <a:r>
               <a:rPr lang="en-US" sz="1800" b="1" dirty="0">
                 <a:solidFill>
-                  <a:srgbClr val="FFFFFF"/>
+                  <a:srgbClr val="17222C"/>
                 </a:solidFill>
                 <a:latin typeface="Arial" pitchFamily="34" charset="0"/>
                 <a:ea typeface="Arial" pitchFamily="34" charset="-122"/>
@@ -8153,7 +8153,7 @@
             <a:r>
               <a:rPr lang="en-US" sz="1200" dirty="0">
                 <a:solidFill>
-                  <a:srgbClr val="7A8C9E"/>
+                  <a:srgbClr val="5C6B7A"/>
                 </a:solidFill>
                 <a:latin typeface="Calibri" pitchFamily="34" charset="0"/>
                 <a:ea typeface="Calibri" pitchFamily="34" charset="-122"/>

</xml_diff>